<commit_message>
fixes formatting and typos
</commit_message>
<xml_diff>
--- a/RefactorToEcIntro.pptx
+++ b/RefactorToEcIntro.pptx
@@ -123,6 +123,11 @@
       </a:defRPr>
     </a:lvl9pPr>
   </p:defaultTextStyle>
+  <p:extLst>
+    <p:ext uri="{EFAFB233-063F-42B5-8137-9DF3F51BA10A}">
+      <p15:sldGuideLst xmlns:p15="http://schemas.microsoft.com/office/powerpoint/2012/main"/>
+    </p:ext>
+  </p:extLst>
 </p:presentation>
 </file>
 
@@ -1366,7 +1371,7 @@
         </p:nvSpPr>
         <p:spPr>
           <a:xfrm>
-            <a:off x="838200" y="1064842"/>
+            <a:off x="838200" y="960120"/>
             <a:ext cx="10515601" cy="1"/>
           </a:xfrm>
           <a:prstGeom prst="line">
@@ -2494,7 +2499,7 @@
         </p:nvSpPr>
         <p:spPr>
           <a:xfrm>
-            <a:off x="838200" y="1064842"/>
+            <a:off x="838200" y="960120"/>
             <a:ext cx="10515601" cy="1"/>
           </a:xfrm>
           <a:prstGeom prst="line">
@@ -3286,9 +3291,7 @@
           <a:prstGeom prst="rect">
             <a:avLst/>
           </a:prstGeom>
-          <a:solidFill>
-            <a:schemeClr val="bg1"/>
-          </a:solidFill>
+          <a:noFill/>
         </p:spPr>
         <p:txBody>
           <a:bodyPr vert="horz" lIns="91440" tIns="45720" rIns="91440" bIns="45720" rtlCol="0" anchor="ctr">
@@ -4134,7 +4137,7 @@
           </a:ln>
           <a:extLst>
             <a:ext uri="{C572A759-6A51-4108-AA02-DFA0A04FC94B}">
-              <ma14:wrappingTextBoxFlag xmlns:ma14="http://schemas.microsoft.com/office/mac/drawingml/2011/main" xmlns="" val="1"/>
+              <ma14:wrappingTextBoxFlag xmlns="" xmlns:ma14="http://schemas.microsoft.com/office/mac/drawingml/2011/main" val="1"/>
             </a:ext>
           </a:extLst>
         </p:spPr>
@@ -4420,7 +4423,7 @@
                 </a:solidFill>
                 <a:latin typeface="Aptos" panose="020B0004020202020204" pitchFamily="34" charset="0"/>
               </a:rPr>
-              <a:t>Donal Raab, Vladimir Zakharov</a:t>
+              <a:t>Donald Raab, Vladimir Zakharov</a:t>
             </a:r>
           </a:p>
           <a:p>
@@ -4561,7 +4564,7 @@
           </a:ln>
           <a:extLst>
             <a:ext uri="{C572A759-6A51-4108-AA02-DFA0A04FC94B}">
-              <ma14:wrappingTextBoxFlag xmlns:ma14="http://schemas.microsoft.com/office/mac/drawingml/2011/main" xmlns="" val="1"/>
+              <ma14:wrappingTextBoxFlag xmlns="" xmlns:ma14="http://schemas.microsoft.com/office/mac/drawingml/2011/main" val="1"/>
             </a:ext>
           </a:extLst>
         </p:spPr>
@@ -11017,7 +11020,7 @@
           </a:ln>
           <a:extLst>
             <a:ext uri="{C572A759-6A51-4108-AA02-DFA0A04FC94B}">
-              <ma14:wrappingTextBoxFlag xmlns:ma14="http://schemas.microsoft.com/office/mac/drawingml/2011/main" xmlns="" val="1"/>
+              <ma14:wrappingTextBoxFlag xmlns="" xmlns:ma14="http://schemas.microsoft.com/office/mac/drawingml/2011/main" val="1"/>
             </a:ext>
           </a:extLst>
         </p:spPr>
@@ -11521,8 +11524,8 @@
         </p:blipFill>
         <p:spPr>
           <a:xfrm>
-            <a:off x="8718083" y="2471735"/>
-            <a:ext cx="2990884" cy="3848565"/>
+            <a:off x="9018322" y="2879331"/>
+            <a:ext cx="2416894" cy="3109975"/>
           </a:xfrm>
           <a:prstGeom prst="rect">
             <a:avLst/>
@@ -11567,7 +11570,7 @@
         </p:blipFill>
         <p:spPr>
           <a:xfrm>
-            <a:off x="704688" y="3103681"/>
+            <a:off x="783272" y="3057735"/>
             <a:ext cx="2224384" cy="2753166"/>
           </a:xfrm>
           <a:prstGeom prst="rect">
@@ -11613,7 +11616,7 @@
         </p:blipFill>
         <p:spPr>
           <a:xfrm>
-            <a:off x="3204512" y="3001707"/>
+            <a:off x="3356981" y="3001708"/>
             <a:ext cx="2321742" cy="2865221"/>
           </a:xfrm>
           <a:prstGeom prst="rect">
@@ -11659,7 +11662,7 @@
         </p:blipFill>
         <p:spPr>
           <a:xfrm>
-            <a:off x="5801694" y="2746444"/>
+            <a:off x="6028048" y="2746444"/>
             <a:ext cx="2640950" cy="3375748"/>
           </a:xfrm>
           <a:prstGeom prst="rect">
@@ -12633,7 +12636,7 @@
           </a:ln>
           <a:extLst>
             <a:ext uri="{C572A759-6A51-4108-AA02-DFA0A04FC94B}">
-              <ma14:wrappingTextBoxFlag xmlns:ma14="http://schemas.microsoft.com/office/mac/drawingml/2011/main" xmlns="" val="1"/>
+              <ma14:wrappingTextBoxFlag xmlns="" xmlns:ma14="http://schemas.microsoft.com/office/mac/drawingml/2011/main" val="1"/>
             </a:ext>
           </a:extLst>
         </p:spPr>
@@ -13027,7 +13030,7 @@
             <a:effectLst/>
             <a:extLst>
               <a:ext uri="{C572A759-6A51-4108-AA02-DFA0A04FC94B}">
-                <ma14:wrappingTextBoxFlag xmlns:ma14="http://schemas.microsoft.com/office/mac/drawingml/2011/main" xmlns="" val="1"/>
+                <ma14:wrappingTextBoxFlag xmlns="" xmlns:ma14="http://schemas.microsoft.com/office/mac/drawingml/2011/main" val="1"/>
               </a:ext>
             </a:extLst>
           </p:spPr>
@@ -13130,7 +13133,7 @@
             <a:effectLst/>
             <a:extLst>
               <a:ext uri="{C572A759-6A51-4108-AA02-DFA0A04FC94B}">
-                <ma14:wrappingTextBoxFlag xmlns:ma14="http://schemas.microsoft.com/office/mac/drawingml/2011/main" xmlns="" val="1"/>
+                <ma14:wrappingTextBoxFlag xmlns="" xmlns:ma14="http://schemas.microsoft.com/office/mac/drawingml/2011/main" val="1"/>
               </a:ext>
             </a:extLst>
           </p:spPr>
@@ -13234,7 +13237,7 @@
             <a:effectLst/>
             <a:extLst>
               <a:ext uri="{C572A759-6A51-4108-AA02-DFA0A04FC94B}">
-                <ma14:wrappingTextBoxFlag xmlns:ma14="http://schemas.microsoft.com/office/mac/drawingml/2011/main" xmlns="" val="1"/>
+                <ma14:wrappingTextBoxFlag xmlns="" xmlns:ma14="http://schemas.microsoft.com/office/mac/drawingml/2011/main" val="1"/>
               </a:ext>
             </a:extLst>
           </p:spPr>
@@ -13337,7 +13340,7 @@
             <a:effectLst/>
             <a:extLst>
               <a:ext uri="{C572A759-6A51-4108-AA02-DFA0A04FC94B}">
-                <ma14:wrappingTextBoxFlag xmlns:ma14="http://schemas.microsoft.com/office/mac/drawingml/2011/main" xmlns="" val="1"/>
+                <ma14:wrappingTextBoxFlag xmlns="" xmlns:ma14="http://schemas.microsoft.com/office/mac/drawingml/2011/main" val="1"/>
               </a:ext>
             </a:extLst>
           </p:spPr>
@@ -13440,7 +13443,7 @@
             <a:effectLst/>
             <a:extLst>
               <a:ext uri="{C572A759-6A51-4108-AA02-DFA0A04FC94B}">
-                <ma14:wrappingTextBoxFlag xmlns:ma14="http://schemas.microsoft.com/office/mac/drawingml/2011/main" xmlns="" val="1"/>
+                <ma14:wrappingTextBoxFlag xmlns="" xmlns:ma14="http://schemas.microsoft.com/office/mac/drawingml/2011/main" val="1"/>
               </a:ext>
             </a:extLst>
           </p:spPr>
@@ -13548,7 +13551,7 @@
             <a:effectLst/>
             <a:extLst>
               <a:ext uri="{C572A759-6A51-4108-AA02-DFA0A04FC94B}">
-                <ma14:wrappingTextBoxFlag xmlns:ma14="http://schemas.microsoft.com/office/mac/drawingml/2011/main" xmlns="" val="1"/>
+                <ma14:wrappingTextBoxFlag xmlns="" xmlns:ma14="http://schemas.microsoft.com/office/mac/drawingml/2011/main" val="1"/>
               </a:ext>
             </a:extLst>
           </p:spPr>
@@ -13651,7 +13654,7 @@
             <a:effectLst/>
             <a:extLst>
               <a:ext uri="{C572A759-6A51-4108-AA02-DFA0A04FC94B}">
-                <ma14:wrappingTextBoxFlag xmlns:ma14="http://schemas.microsoft.com/office/mac/drawingml/2011/main" xmlns="" val="1"/>
+                <ma14:wrappingTextBoxFlag xmlns="" xmlns:ma14="http://schemas.microsoft.com/office/mac/drawingml/2011/main" val="1"/>
               </a:ext>
             </a:extLst>
           </p:spPr>
@@ -13754,7 +13757,7 @@
             <a:effectLst/>
             <a:extLst>
               <a:ext uri="{C572A759-6A51-4108-AA02-DFA0A04FC94B}">
-                <ma14:wrappingTextBoxFlag xmlns:ma14="http://schemas.microsoft.com/office/mac/drawingml/2011/main" xmlns="" val="1"/>
+                <ma14:wrappingTextBoxFlag xmlns="" xmlns:ma14="http://schemas.microsoft.com/office/mac/drawingml/2011/main" val="1"/>
               </a:ext>
             </a:extLst>
           </p:spPr>
@@ -13868,7 +13871,7 @@
             <a:effectLst/>
             <a:extLst>
               <a:ext uri="{C572A759-6A51-4108-AA02-DFA0A04FC94B}">
-                <ma14:wrappingTextBoxFlag xmlns:ma14="http://schemas.microsoft.com/office/mac/drawingml/2011/main" xmlns="" val="1"/>
+                <ma14:wrappingTextBoxFlag xmlns="" xmlns:ma14="http://schemas.microsoft.com/office/mac/drawingml/2011/main" val="1"/>
               </a:ext>
             </a:extLst>
           </p:spPr>
@@ -14081,7 +14084,7 @@
               <a:effectLst/>
               <a:extLst>
                 <a:ext uri="{C572A759-6A51-4108-AA02-DFA0A04FC94B}">
-                  <ma14:wrappingTextBoxFlag xmlns:ma14="http://schemas.microsoft.com/office/mac/drawingml/2011/main" xmlns="" val="1"/>
+                  <ma14:wrappingTextBoxFlag xmlns="" xmlns:ma14="http://schemas.microsoft.com/office/mac/drawingml/2011/main" val="1"/>
                 </a:ext>
               </a:extLst>
             </p:spPr>
@@ -14185,7 +14188,7 @@
             <a:effectLst/>
             <a:extLst>
               <a:ext uri="{C572A759-6A51-4108-AA02-DFA0A04FC94B}">
-                <ma14:wrappingTextBoxFlag xmlns:ma14="http://schemas.microsoft.com/office/mac/drawingml/2011/main" xmlns="" val="1"/>
+                <ma14:wrappingTextBoxFlag xmlns="" xmlns:ma14="http://schemas.microsoft.com/office/mac/drawingml/2011/main" val="1"/>
               </a:ext>
             </a:extLst>
           </p:spPr>
@@ -14288,7 +14291,7 @@
             <a:effectLst/>
             <a:extLst>
               <a:ext uri="{C572A759-6A51-4108-AA02-DFA0A04FC94B}">
-                <ma14:wrappingTextBoxFlag xmlns:ma14="http://schemas.microsoft.com/office/mac/drawingml/2011/main" xmlns="" val="1"/>
+                <ma14:wrappingTextBoxFlag xmlns="" xmlns:ma14="http://schemas.microsoft.com/office/mac/drawingml/2011/main" val="1"/>
               </a:ext>
             </a:extLst>
           </p:spPr>
@@ -14445,7 +14448,7 @@
               <a:effectLst/>
               <a:extLst>
                 <a:ext uri="{C572A759-6A51-4108-AA02-DFA0A04FC94B}">
-                  <ma14:wrappingTextBoxFlag xmlns:ma14="http://schemas.microsoft.com/office/mac/drawingml/2011/main" xmlns="" val="1"/>
+                  <ma14:wrappingTextBoxFlag xmlns="" xmlns:ma14="http://schemas.microsoft.com/office/mac/drawingml/2011/main" val="1"/>
                 </a:ext>
               </a:extLst>
             </p:spPr>
@@ -14603,7 +14606,7 @@
               <a:effectLst/>
               <a:extLst>
                 <a:ext uri="{C572A759-6A51-4108-AA02-DFA0A04FC94B}">
-                  <ma14:wrappingTextBoxFlag xmlns:ma14="http://schemas.microsoft.com/office/mac/drawingml/2011/main" xmlns="" val="1"/>
+                  <ma14:wrappingTextBoxFlag xmlns="" xmlns:ma14="http://schemas.microsoft.com/office/mac/drawingml/2011/main" val="1"/>
                 </a:ext>
               </a:extLst>
             </p:spPr>
@@ -14622,8 +14625,10 @@
               </a:lstStyle>
               <a:p>
                 <a:r>
+                  <a:rPr dirty="0" err="1"/>
                   <a:t>TestUtils</a:t>
                 </a:r>
+                <a:endParaRPr dirty="0"/>
               </a:p>
             </p:txBody>
           </p:sp>
@@ -14978,7 +14983,7 @@
               <a:effectLst/>
               <a:extLst>
                 <a:ext uri="{C572A759-6A51-4108-AA02-DFA0A04FC94B}">
-                  <ma14:wrappingTextBoxFlag xmlns:ma14="http://schemas.microsoft.com/office/mac/drawingml/2011/main" xmlns="" val="1"/>
+                  <ma14:wrappingTextBoxFlag xmlns="" xmlns:ma14="http://schemas.microsoft.com/office/mac/drawingml/2011/main" val="1"/>
                 </a:ext>
               </a:extLst>
             </p:spPr>
@@ -15139,7 +15144,7 @@
               <a:effectLst/>
               <a:extLst>
                 <a:ext uri="{C572A759-6A51-4108-AA02-DFA0A04FC94B}">
-                  <ma14:wrappingTextBoxFlag xmlns:ma14="http://schemas.microsoft.com/office/mac/drawingml/2011/main" xmlns="" val="1"/>
+                  <ma14:wrappingTextBoxFlag xmlns="" xmlns:ma14="http://schemas.microsoft.com/office/mac/drawingml/2011/main" val="1"/>
                 </a:ext>
               </a:extLst>
             </p:spPr>
@@ -15536,7 +15541,7 @@
               <a:effectLst/>
               <a:extLst>
                 <a:ext uri="{C572A759-6A51-4108-AA02-DFA0A04FC94B}">
-                  <ma14:wrappingTextBoxFlag xmlns:ma14="http://schemas.microsoft.com/office/mac/drawingml/2011/main" xmlns="" val="1"/>
+                  <ma14:wrappingTextBoxFlag xmlns="" xmlns:ma14="http://schemas.microsoft.com/office/mac/drawingml/2011/main" val="1"/>
                 </a:ext>
               </a:extLst>
             </p:spPr>
@@ -15638,7 +15643,7 @@
           </a:ln>
           <a:extLst>
             <a:ext uri="{C572A759-6A51-4108-AA02-DFA0A04FC94B}">
-              <ma14:wrappingTextBoxFlag xmlns:ma14="http://schemas.microsoft.com/office/mac/drawingml/2011/main" xmlns="" val="1"/>
+              <ma14:wrappingTextBoxFlag xmlns="" xmlns:ma14="http://schemas.microsoft.com/office/mac/drawingml/2011/main" val="1"/>
             </a:ext>
           </a:extLst>
         </p:spPr>
@@ -16093,7 +16098,7 @@
               <a:effectLst/>
               <a:extLst>
                 <a:ext uri="{C572A759-6A51-4108-AA02-DFA0A04FC94B}">
-                  <ma14:wrappingTextBoxFlag xmlns:ma14="http://schemas.microsoft.com/office/mac/drawingml/2011/main" xmlns="" val="1"/>
+                  <ma14:wrappingTextBoxFlag xmlns="" xmlns:ma14="http://schemas.microsoft.com/office/mac/drawingml/2011/main" val="1"/>
                 </a:ext>
               </a:extLst>
             </p:spPr>
@@ -16261,7 +16266,7 @@
               <a:effectLst/>
               <a:extLst>
                 <a:ext uri="{C572A759-6A51-4108-AA02-DFA0A04FC94B}">
-                  <ma14:wrappingTextBoxFlag xmlns:ma14="http://schemas.microsoft.com/office/mac/drawingml/2011/main" xmlns="" val="1"/>
+                  <ma14:wrappingTextBoxFlag xmlns="" xmlns:ma14="http://schemas.microsoft.com/office/mac/drawingml/2011/main" val="1"/>
                 </a:ext>
               </a:extLst>
             </p:spPr>
@@ -16881,7 +16886,7 @@
               <a:effectLst/>
               <a:extLst>
                 <a:ext uri="{C572A759-6A51-4108-AA02-DFA0A04FC94B}">
-                  <ma14:wrappingTextBoxFlag xmlns:ma14="http://schemas.microsoft.com/office/mac/drawingml/2011/main" xmlns="" val="1"/>
+                  <ma14:wrappingTextBoxFlag xmlns="" xmlns:ma14="http://schemas.microsoft.com/office/mac/drawingml/2011/main" val="1"/>
                 </a:ext>
               </a:extLst>
             </p:spPr>
@@ -16934,7 +16939,7 @@
           </a:ln>
           <a:extLst>
             <a:ext uri="{C572A759-6A51-4108-AA02-DFA0A04FC94B}">
-              <ma14:wrappingTextBoxFlag xmlns:ma14="http://schemas.microsoft.com/office/mac/drawingml/2011/main" xmlns="" val="1"/>
+              <ma14:wrappingTextBoxFlag xmlns="" xmlns:ma14="http://schemas.microsoft.com/office/mac/drawingml/2011/main" val="1"/>
             </a:ext>
           </a:extLst>
         </p:spPr>
@@ -17223,7 +17228,7 @@
           </a:ln>
           <a:extLst>
             <a:ext uri="{C572A759-6A51-4108-AA02-DFA0A04FC94B}">
-              <ma14:wrappingTextBoxFlag xmlns:ma14="http://schemas.microsoft.com/office/mac/drawingml/2011/main" xmlns="" val="1"/>
+              <ma14:wrappingTextBoxFlag xmlns="" xmlns:ma14="http://schemas.microsoft.com/office/mac/drawingml/2011/main" val="1"/>
             </a:ext>
           </a:extLst>
         </p:spPr>
@@ -17543,7 +17548,13 @@
         <p:nvGraphicFramePr>
           <p:cNvPr id="238" name="Table 3"/>
           <p:cNvGraphicFramePr/>
-          <p:nvPr/>
+          <p:nvPr>
+            <p:extLst>
+              <p:ext uri="{D42A27DB-BD31-4B8C-83A1-F6EECF244321}">
+                <p14:modId xmlns:p14="http://schemas.microsoft.com/office/powerpoint/2010/main" val="1522430867"/>
+              </p:ext>
+            </p:extLst>
+          </p:nvPr>
         </p:nvGraphicFramePr>
         <p:xfrm>
           <a:off x="1052945" y="1294627"/>
@@ -17614,15 +17625,33 @@
                   </a:txBody>
                   <a:tcPr marL="45720" marR="45720" anchor="b" horzOverflow="overflow">
                     <a:lnL w="38100">
+                      <a:noFill/>
+                    </a:lnL>
+                    <a:lnR w="12700" cmpd="sng">
+                      <a:noFill/>
+                      <a:prstDash val="solid"/>
+                    </a:lnR>
+                    <a:lnT w="12700" cmpd="sng">
+                      <a:noFill/>
+                      <a:prstDash val="solid"/>
+                    </a:lnT>
+                    <a:lnB w="12700" cap="flat" cmpd="sng" algn="ctr">
                       <a:solidFill>
-                        <a:srgbClr val="FFFFFF"/>
+                        <a:schemeClr val="tx1"/>
                       </a:solidFill>
-                    </a:lnL>
-                    <a:lnB w="12700">
-                      <a:solidFill>
-                        <a:srgbClr val="000000"/>
-                      </a:solidFill>
+                      <a:prstDash val="solid"/>
+                      <a:round/>
+                      <a:headEnd type="none" w="med" len="med"/>
+                      <a:tailEnd type="none" w="med" len="med"/>
                     </a:lnB>
+                    <a:lnTlToBr w="12700" cmpd="sng">
+                      <a:noFill/>
+                      <a:prstDash val="solid"/>
+                    </a:lnTlToBr>
+                    <a:lnBlToTr w="12700" cmpd="sng">
+                      <a:noFill/>
+                      <a:prstDash val="solid"/>
+                    </a:lnBlToTr>
                   </a:tcPr>
                 </a:tc>
                 <a:tc>
@@ -17640,11 +17669,35 @@
                     </a:p>
                   </a:txBody>
                   <a:tcPr marL="45720" marR="45720" anchor="b" horzOverflow="overflow">
-                    <a:lnB w="12700">
+                    <a:lnL w="12700" cmpd="sng">
+                      <a:noFill/>
+                      <a:prstDash val="solid"/>
+                    </a:lnL>
+                    <a:lnR w="12700" cmpd="sng">
+                      <a:noFill/>
+                      <a:prstDash val="solid"/>
+                    </a:lnR>
+                    <a:lnT w="12700" cmpd="sng">
+                      <a:noFill/>
+                      <a:prstDash val="solid"/>
+                    </a:lnT>
+                    <a:lnB w="12700" cap="flat" cmpd="sng" algn="ctr">
                       <a:solidFill>
-                        <a:srgbClr val="000000"/>
+                        <a:schemeClr val="tx1"/>
                       </a:solidFill>
+                      <a:prstDash val="solid"/>
+                      <a:round/>
+                      <a:headEnd type="none" w="med" len="med"/>
+                      <a:tailEnd type="none" w="med" len="med"/>
                     </a:lnB>
+                    <a:lnTlToBr w="12700" cmpd="sng">
+                      <a:noFill/>
+                      <a:prstDash val="solid"/>
+                    </a:lnTlToBr>
+                    <a:lnBlToTr w="12700" cmpd="sng">
+                      <a:noFill/>
+                      <a:prstDash val="solid"/>
+                    </a:lnBlToTr>
                   </a:tcPr>
                 </a:tc>
                 <a:tc>
@@ -17662,11 +17715,35 @@
                     </a:p>
                   </a:txBody>
                   <a:tcPr marL="45720" marR="45720" anchor="b" horzOverflow="overflow">
-                    <a:lnB w="12700">
+                    <a:lnL w="12700" cmpd="sng">
+                      <a:noFill/>
+                      <a:prstDash val="solid"/>
+                    </a:lnL>
+                    <a:lnR w="12700" cmpd="sng">
+                      <a:noFill/>
+                      <a:prstDash val="solid"/>
+                    </a:lnR>
+                    <a:lnT w="12700" cmpd="sng">
+                      <a:noFill/>
+                      <a:prstDash val="solid"/>
+                    </a:lnT>
+                    <a:lnB w="12700" cap="flat" cmpd="sng" algn="ctr">
                       <a:solidFill>
-                        <a:srgbClr val="000000"/>
+                        <a:schemeClr val="tx1"/>
                       </a:solidFill>
+                      <a:prstDash val="solid"/>
+                      <a:round/>
+                      <a:headEnd type="none" w="med" len="med"/>
+                      <a:tailEnd type="none" w="med" len="med"/>
                     </a:lnB>
+                    <a:lnTlToBr w="12700" cmpd="sng">
+                      <a:noFill/>
+                      <a:prstDash val="solid"/>
+                    </a:lnTlToBr>
+                    <a:lnBlToTr w="12700" cmpd="sng">
+                      <a:noFill/>
+                      <a:prstDash val="solid"/>
+                    </a:lnBlToTr>
                   </a:tcPr>
                 </a:tc>
                 <a:tc>
@@ -17684,11 +17761,35 @@
                     </a:p>
                   </a:txBody>
                   <a:tcPr marL="45720" marR="45720" anchor="b" horzOverflow="overflow">
-                    <a:lnB w="12700">
+                    <a:lnL w="12700" cmpd="sng">
+                      <a:noFill/>
+                      <a:prstDash val="solid"/>
+                    </a:lnL>
+                    <a:lnR w="12700" cmpd="sng">
+                      <a:noFill/>
+                      <a:prstDash val="solid"/>
+                    </a:lnR>
+                    <a:lnT w="12700" cmpd="sng">
+                      <a:noFill/>
+                      <a:prstDash val="solid"/>
+                    </a:lnT>
+                    <a:lnB w="12700" cap="flat" cmpd="sng" algn="ctr">
                       <a:solidFill>
-                        <a:srgbClr val="000000"/>
+                        <a:schemeClr val="tx1"/>
                       </a:solidFill>
+                      <a:prstDash val="solid"/>
+                      <a:round/>
+                      <a:headEnd type="none" w="med" len="med"/>
+                      <a:tailEnd type="none" w="med" len="med"/>
                     </a:lnB>
+                    <a:lnTlToBr w="12700" cmpd="sng">
+                      <a:noFill/>
+                      <a:prstDash val="solid"/>
+                    </a:lnTlToBr>
+                    <a:lnBlToTr w="12700" cmpd="sng">
+                      <a:noFill/>
+                      <a:prstDash val="solid"/>
+                    </a:lnBlToTr>
                   </a:tcPr>
                 </a:tc>
                 <a:tc>
@@ -17706,11 +17807,35 @@
                     </a:p>
                   </a:txBody>
                   <a:tcPr marL="45720" marR="45720" anchor="b" horzOverflow="overflow">
-                    <a:lnB w="12700">
+                    <a:lnL w="12700" cmpd="sng">
+                      <a:noFill/>
+                      <a:prstDash val="solid"/>
+                    </a:lnL>
+                    <a:lnR w="12700" cmpd="sng">
+                      <a:noFill/>
+                      <a:prstDash val="solid"/>
+                    </a:lnR>
+                    <a:lnT w="12700" cmpd="sng">
+                      <a:noFill/>
+                      <a:prstDash val="solid"/>
+                    </a:lnT>
+                    <a:lnB w="12700" cap="flat" cmpd="sng" algn="ctr">
                       <a:solidFill>
-                        <a:srgbClr val="000000"/>
+                        <a:schemeClr val="tx1"/>
                       </a:solidFill>
+                      <a:prstDash val="solid"/>
+                      <a:round/>
+                      <a:headEnd type="none" w="med" len="med"/>
+                      <a:tailEnd type="none" w="med" len="med"/>
                     </a:lnB>
+                    <a:lnTlToBr w="12700" cmpd="sng">
+                      <a:noFill/>
+                      <a:prstDash val="solid"/>
+                    </a:lnTlToBr>
+                    <a:lnBlToTr w="12700" cmpd="sng">
+                      <a:noFill/>
+                      <a:prstDash val="solid"/>
+                    </a:lnBlToTr>
                   </a:tcPr>
                 </a:tc>
                 <a:tc>
@@ -17722,17 +17847,41 @@
                         <a:defRPr sz="1800"/>
                       </a:pPr>
                       <a:r>
-                        <a:rPr b="1"/>
+                        <a:rPr b="1" dirty="0"/>
                         <a:t>Lazy</a:t>
                       </a:r>
                     </a:p>
                   </a:txBody>
                   <a:tcPr marL="45720" marR="45720" anchor="b" horzOverflow="overflow">
-                    <a:lnB w="12700">
+                    <a:lnL w="12700" cmpd="sng">
+                      <a:noFill/>
+                      <a:prstDash val="solid"/>
+                    </a:lnL>
+                    <a:lnR w="12700" cmpd="sng">
+                      <a:noFill/>
+                      <a:prstDash val="solid"/>
+                    </a:lnR>
+                    <a:lnT w="12700" cmpd="sng">
+                      <a:noFill/>
+                      <a:prstDash val="solid"/>
+                    </a:lnT>
+                    <a:lnB w="12700" cap="flat" cmpd="sng" algn="ctr">
                       <a:solidFill>
-                        <a:srgbClr val="000000"/>
+                        <a:schemeClr val="tx1"/>
                       </a:solidFill>
+                      <a:prstDash val="solid"/>
+                      <a:round/>
+                      <a:headEnd type="none" w="med" len="med"/>
+                      <a:tailEnd type="none" w="med" len="med"/>
                     </a:lnB>
+                    <a:lnTlToBr w="12700" cmpd="sng">
+                      <a:noFill/>
+                      <a:prstDash val="solid"/>
+                    </a:lnTlToBr>
+                    <a:lnBlToTr w="12700" cmpd="sng">
+                      <a:noFill/>
+                      <a:prstDash val="solid"/>
+                    </a:lnBlToTr>
                   </a:tcPr>
                 </a:tc>
                 <a:extLst>
@@ -17857,15 +18006,33 @@
                   </a:txBody>
                   <a:tcPr marL="45720" marR="45720" horzOverflow="overflow">
                     <a:lnL w="38100">
+                      <a:noFill/>
+                    </a:lnL>
+                    <a:lnR w="12700" cmpd="sng">
+                      <a:noFill/>
+                      <a:prstDash val="solid"/>
+                    </a:lnR>
+                    <a:lnT w="12700" cap="flat" cmpd="sng" algn="ctr">
                       <a:solidFill>
-                        <a:srgbClr val="FFFFFF"/>
+                        <a:schemeClr val="tx1"/>
                       </a:solidFill>
-                    </a:lnL>
-                    <a:lnT w="12700">
-                      <a:solidFill>
-                        <a:srgbClr val="000000"/>
-                      </a:solidFill>
+                      <a:prstDash val="solid"/>
+                      <a:round/>
+                      <a:headEnd type="none" w="med" len="med"/>
+                      <a:tailEnd type="none" w="med" len="med"/>
                     </a:lnT>
+                    <a:lnB w="12700" cmpd="sng">
+                      <a:noFill/>
+                      <a:prstDash val="solid"/>
+                    </a:lnB>
+                    <a:lnTlToBr w="12700" cmpd="sng">
+                      <a:noFill/>
+                      <a:prstDash val="solid"/>
+                    </a:lnTlToBr>
+                    <a:lnBlToTr w="12700" cmpd="sng">
+                      <a:noFill/>
+                      <a:prstDash val="solid"/>
+                    </a:lnBlToTr>
                   </a:tcPr>
                 </a:tc>
                 <a:tc>
@@ -17882,6 +18049,7 @@
                         </a:defRPr>
                       </a:pPr>
                       <a:r>
+                        <a:rPr dirty="0"/>
                         <a:t>Bags</a:t>
                       </a:r>
                     </a:p>
@@ -17895,8 +18063,10 @@
                         </a:defRPr>
                       </a:pPr>
                       <a:r>
+                        <a:rPr dirty="0" err="1"/>
                         <a:t>BiMaps</a:t>
                       </a:r>
+                      <a:endParaRPr dirty="0"/>
                     </a:p>
                     <a:p>
                       <a:pPr algn="l">
@@ -17908,6 +18078,7 @@
                         </a:defRPr>
                       </a:pPr>
                       <a:r>
+                        <a:rPr dirty="0"/>
                         <a:t>Lists</a:t>
                       </a:r>
                     </a:p>
@@ -17921,6 +18092,7 @@
                         </a:defRPr>
                       </a:pPr>
                       <a:r>
+                        <a:rPr dirty="0"/>
                         <a:t>Maps</a:t>
                       </a:r>
                     </a:p>
@@ -17934,6 +18106,7 @@
                         </a:defRPr>
                       </a:pPr>
                       <a:r>
+                        <a:rPr dirty="0"/>
                         <a:t>Multimaps</a:t>
                       </a:r>
                     </a:p>
@@ -17947,6 +18120,7 @@
                         </a:defRPr>
                       </a:pPr>
                       <a:r>
+                        <a:rPr dirty="0"/>
                         <a:t>Sets</a:t>
                       </a:r>
                     </a:p>
@@ -17960,8 +18134,10 @@
                         </a:defRPr>
                       </a:pPr>
                       <a:r>
+                        <a:rPr dirty="0" err="1"/>
                         <a:t>SortedBags</a:t>
                       </a:r>
+                      <a:endParaRPr dirty="0"/>
                     </a:p>
                     <a:p>
                       <a:pPr algn="l">
@@ -17973,8 +18149,10 @@
                         </a:defRPr>
                       </a:pPr>
                       <a:r>
+                        <a:rPr dirty="0" err="1"/>
                         <a:t>SortedMaps</a:t>
                       </a:r>
+                      <a:endParaRPr dirty="0"/>
                     </a:p>
                     <a:p>
                       <a:pPr algn="l">
@@ -17986,8 +18164,10 @@
                         </a:defRPr>
                       </a:pPr>
                       <a:r>
+                        <a:rPr dirty="0" err="1"/>
                         <a:t>SortedSets</a:t>
                       </a:r>
+                      <a:endParaRPr dirty="0"/>
                     </a:p>
                     <a:p>
                       <a:pPr algn="l">
@@ -17999,16 +18179,41 @@
                         </a:defRPr>
                       </a:pPr>
                       <a:r>
+                        <a:rPr dirty="0"/>
                         <a:t>Stacks</a:t>
                       </a:r>
                     </a:p>
                   </a:txBody>
                   <a:tcPr marL="45720" marR="45720" horzOverflow="overflow">
-                    <a:lnT w="12700">
+                    <a:lnL w="12700" cmpd="sng">
+                      <a:noFill/>
+                      <a:prstDash val="solid"/>
+                    </a:lnL>
+                    <a:lnR w="12700" cmpd="sng">
+                      <a:noFill/>
+                      <a:prstDash val="solid"/>
+                    </a:lnR>
+                    <a:lnT w="12700" cap="flat" cmpd="sng" algn="ctr">
                       <a:solidFill>
-                        <a:srgbClr val="000000"/>
+                        <a:schemeClr val="tx1"/>
                       </a:solidFill>
+                      <a:prstDash val="solid"/>
+                      <a:round/>
+                      <a:headEnd type="none" w="med" len="med"/>
+                      <a:tailEnd type="none" w="med" len="med"/>
                     </a:lnT>
+                    <a:lnB w="12700" cmpd="sng">
+                      <a:noFill/>
+                      <a:prstDash val="solid"/>
+                    </a:lnB>
+                    <a:lnTlToBr w="12700" cmpd="sng">
+                      <a:noFill/>
+                      <a:prstDash val="solid"/>
+                    </a:lnTlToBr>
+                    <a:lnBlToTr w="12700" cmpd="sng">
+                      <a:noFill/>
+                      <a:prstDash val="solid"/>
+                    </a:lnBlToTr>
                   </a:tcPr>
                 </a:tc>
                 <a:tc>
@@ -18033,11 +18238,35 @@
                     </a:p>
                   </a:txBody>
                   <a:tcPr marL="45720" marR="45720" horzOverflow="overflow">
-                    <a:lnT w="12700">
+                    <a:lnL w="12700" cmpd="sng">
+                      <a:noFill/>
+                      <a:prstDash val="solid"/>
+                    </a:lnL>
+                    <a:lnR w="12700" cmpd="sng">
+                      <a:noFill/>
+                      <a:prstDash val="solid"/>
+                    </a:lnR>
+                    <a:lnT w="12700" cap="flat" cmpd="sng" algn="ctr">
                       <a:solidFill>
-                        <a:srgbClr val="000000"/>
+                        <a:schemeClr val="tx1"/>
                       </a:solidFill>
+                      <a:prstDash val="solid"/>
+                      <a:round/>
+                      <a:headEnd type="none" w="med" len="med"/>
+                      <a:tailEnd type="none" w="med" len="med"/>
                     </a:lnT>
+                    <a:lnB w="12700" cmpd="sng">
+                      <a:noFill/>
+                      <a:prstDash val="solid"/>
+                    </a:lnB>
+                    <a:lnTlToBr w="12700" cmpd="sng">
+                      <a:noFill/>
+                      <a:prstDash val="solid"/>
+                    </a:lnTlToBr>
+                    <a:lnBlToTr w="12700" cmpd="sng">
+                      <a:noFill/>
+                      <a:prstDash val="solid"/>
+                    </a:lnBlToTr>
                   </a:tcPr>
                 </a:tc>
                 <a:tc>
@@ -18063,11 +18292,35 @@
                     </a:p>
                   </a:txBody>
                   <a:tcPr marL="45720" marR="45720" horzOverflow="overflow">
-                    <a:lnT w="12700">
+                    <a:lnL w="12700" cmpd="sng">
+                      <a:noFill/>
+                      <a:prstDash val="solid"/>
+                    </a:lnL>
+                    <a:lnR w="12700" cmpd="sng">
+                      <a:noFill/>
+                      <a:prstDash val="solid"/>
+                    </a:lnR>
+                    <a:lnT w="12700" cap="flat" cmpd="sng" algn="ctr">
                       <a:solidFill>
-                        <a:srgbClr val="000000"/>
+                        <a:schemeClr val="tx1"/>
                       </a:solidFill>
+                      <a:prstDash val="solid"/>
+                      <a:round/>
+                      <a:headEnd type="none" w="med" len="med"/>
+                      <a:tailEnd type="none" w="med" len="med"/>
                     </a:lnT>
+                    <a:lnB w="12700" cmpd="sng">
+                      <a:noFill/>
+                      <a:prstDash val="solid"/>
+                    </a:lnB>
+                    <a:lnTlToBr w="12700" cmpd="sng">
+                      <a:noFill/>
+                      <a:prstDash val="solid"/>
+                    </a:lnTlToBr>
+                    <a:lnBlToTr w="12700" cmpd="sng">
+                      <a:noFill/>
+                      <a:prstDash val="solid"/>
+                    </a:lnBlToTr>
                   </a:tcPr>
                 </a:tc>
                 <a:tc>
@@ -18226,11 +18479,35 @@
                     </a:p>
                   </a:txBody>
                   <a:tcPr marL="45720" marR="45720" horzOverflow="overflow">
-                    <a:lnT w="12700">
+                    <a:lnL w="12700" cmpd="sng">
+                      <a:noFill/>
+                      <a:prstDash val="solid"/>
+                    </a:lnL>
+                    <a:lnR w="12700" cmpd="sng">
+                      <a:noFill/>
+                      <a:prstDash val="solid"/>
+                    </a:lnR>
+                    <a:lnT w="12700" cap="flat" cmpd="sng" algn="ctr">
                       <a:solidFill>
-                        <a:srgbClr val="000000"/>
+                        <a:schemeClr val="tx1"/>
                       </a:solidFill>
+                      <a:prstDash val="solid"/>
+                      <a:round/>
+                      <a:headEnd type="none" w="med" len="med"/>
+                      <a:tailEnd type="none" w="med" len="med"/>
                     </a:lnT>
+                    <a:lnB w="12700" cmpd="sng">
+                      <a:noFill/>
+                      <a:prstDash val="solid"/>
+                    </a:lnB>
+                    <a:lnTlToBr w="12700" cmpd="sng">
+                      <a:noFill/>
+                      <a:prstDash val="solid"/>
+                    </a:lnTlToBr>
+                    <a:lnBlToTr w="12700" cmpd="sng">
+                      <a:noFill/>
+                      <a:prstDash val="solid"/>
+                    </a:lnBlToTr>
                   </a:tcPr>
                 </a:tc>
                 <a:tc>
@@ -18242,22 +18519,64 @@
                         <a:defRPr sz="1800"/>
                       </a:pPr>
                       <a:r>
-                        <a:rPr>
+                        <a:rPr dirty="0">
                           <a:latin typeface="Consolas"/>
                           <a:ea typeface="Consolas"/>
                           <a:cs typeface="Consolas"/>
                           <a:sym typeface="Consolas"/>
                         </a:rPr>
-                        <a:t>.asLazy()</a:t>
+                        <a:t>.</a:t>
+                      </a:r>
+                      <a:r>
+                        <a:rPr dirty="0" err="1">
+                          <a:latin typeface="Consolas"/>
+                          <a:ea typeface="Consolas"/>
+                          <a:cs typeface="Consolas"/>
+                          <a:sym typeface="Consolas"/>
+                        </a:rPr>
+                        <a:t>asLazy</a:t>
+                      </a:r>
+                      <a:r>
+                        <a:rPr dirty="0">
+                          <a:latin typeface="Consolas"/>
+                          <a:ea typeface="Consolas"/>
+                          <a:cs typeface="Consolas"/>
+                          <a:sym typeface="Consolas"/>
+                        </a:rPr>
+                        <a:t>()</a:t>
                       </a:r>
                     </a:p>
                   </a:txBody>
                   <a:tcPr marL="45720" marR="45720" horzOverflow="overflow">
-                    <a:lnT w="12700">
+                    <a:lnL w="12700" cmpd="sng">
+                      <a:noFill/>
+                      <a:prstDash val="solid"/>
+                    </a:lnL>
+                    <a:lnR w="12700" cmpd="sng">
+                      <a:noFill/>
+                      <a:prstDash val="solid"/>
+                    </a:lnR>
+                    <a:lnT w="12700" cap="flat" cmpd="sng" algn="ctr">
                       <a:solidFill>
-                        <a:srgbClr val="000000"/>
+                        <a:schemeClr val="tx1"/>
                       </a:solidFill>
+                      <a:prstDash val="solid"/>
+                      <a:round/>
+                      <a:headEnd type="none" w="med" len="med"/>
+                      <a:tailEnd type="none" w="med" len="med"/>
                     </a:lnT>
+                    <a:lnB w="12700" cmpd="sng">
+                      <a:noFill/>
+                      <a:prstDash val="solid"/>
+                    </a:lnB>
+                    <a:lnTlToBr w="12700" cmpd="sng">
+                      <a:noFill/>
+                      <a:prstDash val="solid"/>
+                    </a:lnTlToBr>
+                    <a:lnBlToTr w="12700" cmpd="sng">
+                      <a:noFill/>
+                      <a:prstDash val="solid"/>
+                    </a:lnBlToTr>
                   </a:tcPr>
                 </a:tc>
                 <a:extLst>
@@ -18289,7 +18608,7 @@
           </a:ln>
           <a:extLst>
             <a:ext uri="{C572A759-6A51-4108-AA02-DFA0A04FC94B}">
-              <ma14:wrappingTextBoxFlag xmlns:ma14="http://schemas.microsoft.com/office/mac/drawingml/2011/main" xmlns="" val="1"/>
+              <ma14:wrappingTextBoxFlag xmlns="" xmlns:ma14="http://schemas.microsoft.com/office/mac/drawingml/2011/main" val="1"/>
             </a:ext>
           </a:extLst>
         </p:spPr>
@@ -18597,7 +18916,7 @@
           </a:ln>
           <a:extLst>
             <a:ext uri="{C572A759-6A51-4108-AA02-DFA0A04FC94B}">
-              <ma14:wrappingTextBoxFlag xmlns:ma14="http://schemas.microsoft.com/office/mac/drawingml/2011/main" xmlns="" val="1"/>
+              <ma14:wrappingTextBoxFlag xmlns="" xmlns:ma14="http://schemas.microsoft.com/office/mac/drawingml/2011/main" val="1"/>
             </a:ext>
           </a:extLst>
         </p:spPr>
@@ -18647,7 +18966,7 @@
           </a:ln>
           <a:extLst>
             <a:ext uri="{C572A759-6A51-4108-AA02-DFA0A04FC94B}">
-              <ma14:wrappingTextBoxFlag xmlns:ma14="http://schemas.microsoft.com/office/mac/drawingml/2011/main" xmlns="" val="1"/>
+              <ma14:wrappingTextBoxFlag xmlns="" xmlns:ma14="http://schemas.microsoft.com/office/mac/drawingml/2011/main" val="1"/>
             </a:ext>
           </a:extLst>
         </p:spPr>
@@ -18816,7 +19135,7 @@
           </a:ln>
           <a:extLst>
             <a:ext uri="{C572A759-6A51-4108-AA02-DFA0A04FC94B}">
-              <ma14:wrappingTextBoxFlag xmlns:ma14="http://schemas.microsoft.com/office/mac/drawingml/2011/main" xmlns="" val="1"/>
+              <ma14:wrappingTextBoxFlag xmlns="" xmlns:ma14="http://schemas.microsoft.com/office/mac/drawingml/2011/main" val="1"/>
             </a:ext>
           </a:extLst>
         </p:spPr>
@@ -19222,7 +19541,7 @@
               <a:effectLst/>
               <a:extLst>
                 <a:ext uri="{C572A759-6A51-4108-AA02-DFA0A04FC94B}">
-                  <ma14:wrappingTextBoxFlag xmlns:ma14="http://schemas.microsoft.com/office/mac/drawingml/2011/main" xmlns="" val="1"/>
+                  <ma14:wrappingTextBoxFlag xmlns="" xmlns:ma14="http://schemas.microsoft.com/office/mac/drawingml/2011/main" val="1"/>
                 </a:ext>
               </a:extLst>
             </p:spPr>
@@ -19267,7 +19586,7 @@
             <a:effectLst/>
             <a:extLst>
               <a:ext uri="{C572A759-6A51-4108-AA02-DFA0A04FC94B}">
-                <ma14:wrappingTextBoxFlag xmlns:ma14="http://schemas.microsoft.com/office/mac/drawingml/2011/main" xmlns="" val="1"/>
+                <ma14:wrappingTextBoxFlag xmlns="" xmlns:ma14="http://schemas.microsoft.com/office/mac/drawingml/2011/main" val="1"/>
               </a:ext>
             </a:extLst>
           </p:spPr>
@@ -19490,7 +19809,7 @@
               <a:effectLst/>
               <a:extLst>
                 <a:ext uri="{C572A759-6A51-4108-AA02-DFA0A04FC94B}">
-                  <ma14:wrappingTextBoxFlag xmlns:ma14="http://schemas.microsoft.com/office/mac/drawingml/2011/main" xmlns="" val="1"/>
+                  <ma14:wrappingTextBoxFlag xmlns="" xmlns:ma14="http://schemas.microsoft.com/office/mac/drawingml/2011/main" val="1"/>
                 </a:ext>
               </a:extLst>
             </p:spPr>
@@ -19535,7 +19854,7 @@
             <a:effectLst/>
             <a:extLst>
               <a:ext uri="{C572A759-6A51-4108-AA02-DFA0A04FC94B}">
-                <ma14:wrappingTextBoxFlag xmlns:ma14="http://schemas.microsoft.com/office/mac/drawingml/2011/main" xmlns="" val="1"/>
+                <ma14:wrappingTextBoxFlag xmlns="" xmlns:ma14="http://schemas.microsoft.com/office/mac/drawingml/2011/main" val="1"/>
               </a:ext>
             </a:extLst>
           </p:spPr>
@@ -19713,7 +20032,7 @@
               <a:effectLst/>
               <a:extLst>
                 <a:ext uri="{C572A759-6A51-4108-AA02-DFA0A04FC94B}">
-                  <ma14:wrappingTextBoxFlag xmlns:ma14="http://schemas.microsoft.com/office/mac/drawingml/2011/main" xmlns="" val="1"/>
+                  <ma14:wrappingTextBoxFlag xmlns="" xmlns:ma14="http://schemas.microsoft.com/office/mac/drawingml/2011/main" val="1"/>
                 </a:ext>
               </a:extLst>
             </p:spPr>
@@ -19758,7 +20077,7 @@
             <a:effectLst/>
             <a:extLst>
               <a:ext uri="{C572A759-6A51-4108-AA02-DFA0A04FC94B}">
-                <ma14:wrappingTextBoxFlag xmlns:ma14="http://schemas.microsoft.com/office/mac/drawingml/2011/main" xmlns="" val="1"/>
+                <ma14:wrappingTextBoxFlag xmlns="" xmlns:ma14="http://schemas.microsoft.com/office/mac/drawingml/2011/main" val="1"/>
               </a:ext>
             </a:extLst>
           </p:spPr>
@@ -20037,7 +20356,7 @@
               <a:effectLst/>
               <a:extLst>
                 <a:ext uri="{C572A759-6A51-4108-AA02-DFA0A04FC94B}">
-                  <ma14:wrappingTextBoxFlag xmlns:ma14="http://schemas.microsoft.com/office/mac/drawingml/2011/main" xmlns="" val="1"/>
+                  <ma14:wrappingTextBoxFlag xmlns="" xmlns:ma14="http://schemas.microsoft.com/office/mac/drawingml/2011/main" val="1"/>
                 </a:ext>
               </a:extLst>
             </p:spPr>
@@ -20082,7 +20401,7 @@
             <a:effectLst/>
             <a:extLst>
               <a:ext uri="{C572A759-6A51-4108-AA02-DFA0A04FC94B}">
-                <ma14:wrappingTextBoxFlag xmlns:ma14="http://schemas.microsoft.com/office/mac/drawingml/2011/main" xmlns="" val="1"/>
+                <ma14:wrappingTextBoxFlag xmlns="" xmlns:ma14="http://schemas.microsoft.com/office/mac/drawingml/2011/main" val="1"/>
               </a:ext>
             </a:extLst>
           </p:spPr>
@@ -20300,7 +20619,7 @@
               <a:effectLst/>
               <a:extLst>
                 <a:ext uri="{C572A759-6A51-4108-AA02-DFA0A04FC94B}">
-                  <ma14:wrappingTextBoxFlag xmlns:ma14="http://schemas.microsoft.com/office/mac/drawingml/2011/main" xmlns="" val="1"/>
+                  <ma14:wrappingTextBoxFlag xmlns="" xmlns:ma14="http://schemas.microsoft.com/office/mac/drawingml/2011/main" val="1"/>
                 </a:ext>
               </a:extLst>
             </p:spPr>
@@ -20348,7 +20667,7 @@
             <a:effectLst/>
             <a:extLst>
               <a:ext uri="{C572A759-6A51-4108-AA02-DFA0A04FC94B}">
-                <ma14:wrappingTextBoxFlag xmlns:ma14="http://schemas.microsoft.com/office/mac/drawingml/2011/main" xmlns="" val="1"/>
+                <ma14:wrappingTextBoxFlag xmlns="" xmlns:ma14="http://schemas.microsoft.com/office/mac/drawingml/2011/main" val="1"/>
               </a:ext>
             </a:extLst>
           </p:spPr>
@@ -20553,7 +20872,7 @@
               <a:effectLst/>
               <a:extLst>
                 <a:ext uri="{C572A759-6A51-4108-AA02-DFA0A04FC94B}">
-                  <ma14:wrappingTextBoxFlag xmlns:ma14="http://schemas.microsoft.com/office/mac/drawingml/2011/main" xmlns="" val="1"/>
+                  <ma14:wrappingTextBoxFlag xmlns="" xmlns:ma14="http://schemas.microsoft.com/office/mac/drawingml/2011/main" val="1"/>
                 </a:ext>
               </a:extLst>
             </p:spPr>
@@ -20601,7 +20920,7 @@
             <a:effectLst/>
             <a:extLst>
               <a:ext uri="{C572A759-6A51-4108-AA02-DFA0A04FC94B}">
-                <ma14:wrappingTextBoxFlag xmlns:ma14="http://schemas.microsoft.com/office/mac/drawingml/2011/main" xmlns="" val="1"/>
+                <ma14:wrappingTextBoxFlag xmlns="" xmlns:ma14="http://schemas.microsoft.com/office/mac/drawingml/2011/main" val="1"/>
               </a:ext>
             </a:extLst>
           </p:spPr>
@@ -20843,7 +21162,7 @@
               <a:effectLst/>
               <a:extLst>
                 <a:ext uri="{C572A759-6A51-4108-AA02-DFA0A04FC94B}">
-                  <ma14:wrappingTextBoxFlag xmlns:ma14="http://schemas.microsoft.com/office/mac/drawingml/2011/main" xmlns="" val="1"/>
+                  <ma14:wrappingTextBoxFlag xmlns="" xmlns:ma14="http://schemas.microsoft.com/office/mac/drawingml/2011/main" val="1"/>
                 </a:ext>
               </a:extLst>
             </p:spPr>
@@ -20891,7 +21210,7 @@
             <a:effectLst/>
             <a:extLst>
               <a:ext uri="{C572A759-6A51-4108-AA02-DFA0A04FC94B}">
-                <ma14:wrappingTextBoxFlag xmlns:ma14="http://schemas.microsoft.com/office/mac/drawingml/2011/main" xmlns="" val="1"/>
+                <ma14:wrappingTextBoxFlag xmlns="" xmlns:ma14="http://schemas.microsoft.com/office/mac/drawingml/2011/main" val="1"/>
               </a:ext>
             </a:extLst>
           </p:spPr>
@@ -21159,7 +21478,7 @@
           </a:ln>
           <a:extLst>
             <a:ext uri="{C572A759-6A51-4108-AA02-DFA0A04FC94B}">
-              <ma14:wrappingTextBoxFlag xmlns:ma14="http://schemas.microsoft.com/office/mac/drawingml/2011/main" xmlns="" val="1"/>
+              <ma14:wrappingTextBoxFlag xmlns="" xmlns:ma14="http://schemas.microsoft.com/office/mac/drawingml/2011/main" val="1"/>
             </a:ext>
           </a:extLst>
         </p:spPr>
@@ -21603,7 +21922,12 @@
             <p:ph type="title"/>
           </p:nvPr>
         </p:nvSpPr>
-        <p:spPr/>
+        <p:spPr>
+          <a:xfrm>
+            <a:off x="838200" y="228600"/>
+            <a:ext cx="10515600" cy="822960"/>
+          </a:xfrm>
+        </p:spPr>
         <p:txBody>
           <a:bodyPr/>
           <a:lstStyle/>
@@ -21632,9 +21956,10 @@
           </p:nvPr>
         </p:nvSpPr>
         <p:spPr>
-          <a:prstGeom prst="rect">
-            <a:avLst/>
-          </a:prstGeom>
+          <a:xfrm>
+            <a:off x="8610600" y="6356350"/>
+            <a:ext cx="2743200" cy="365125"/>
+          </a:xfrm>
           <a:ln w="12700">
             <a:miter lim="400000"/>
           </a:ln>
@@ -21979,7 +22304,7 @@
         </p:blipFill>
         <p:spPr>
           <a:xfrm>
-            <a:off x="1115302" y="1825720"/>
+            <a:off x="2209800" y="1413825"/>
             <a:ext cx="7772400" cy="4708783"/>
           </a:xfrm>
           <a:prstGeom prst="rect">

</xml_diff>

<commit_message>
adds missing castToSet() to the "evolving" slide
</commit_message>
<xml_diff>
--- a/RefactorToEcIntro.pptx
+++ b/RefactorToEcIntro.pptx
@@ -218,7 +218,7 @@
           <a:p>
             <a:fld id="{8CCF7272-9B1D-4C9A-BAA4-A2C3BF62B1D2}" type="datetimeFigureOut">
               <a:rPr lang="en-US" smtClean="0"/>
-              <a:t>9/24/2025</a:t>
+              <a:t>9/25/2025</a:t>
             </a:fld>
             <a:endParaRPr lang="en-US"/>
           </a:p>
@@ -512,6 +512,90 @@
             <p:ph type="sldImg"/>
           </p:nvPr>
         </p:nvSpPr>
+        <p:spPr/>
+      </p:sp>
+      <p:sp>
+        <p:nvSpPr>
+          <p:cNvPr id="3" name="Notes Placeholder 2"/>
+          <p:cNvSpPr>
+            <a:spLocks noGrp="1"/>
+          </p:cNvSpPr>
+          <p:nvPr>
+            <p:ph type="body" idx="1"/>
+          </p:nvPr>
+        </p:nvSpPr>
+        <p:spPr/>
+        <p:txBody>
+          <a:bodyPr/>
+          <a:lstStyle/>
+          <a:p>
+            <a:endParaRPr lang="en-US"/>
+          </a:p>
+        </p:txBody>
+      </p:sp>
+      <p:sp>
+        <p:nvSpPr>
+          <p:cNvPr id="4" name="Slide Number Placeholder 3"/>
+          <p:cNvSpPr>
+            <a:spLocks noGrp="1"/>
+          </p:cNvSpPr>
+          <p:nvPr>
+            <p:ph type="sldNum" sz="quarter" idx="5"/>
+          </p:nvPr>
+        </p:nvSpPr>
+        <p:spPr/>
+        <p:txBody>
+          <a:bodyPr/>
+          <a:lstStyle/>
+          <a:p>
+            <a:fld id="{3009100B-F611-4B83-9AF4-01D82287C5E3}" type="slidenum">
+              <a:rPr lang="en-US" smtClean="0"/>
+              <a:t>6</a:t>
+            </a:fld>
+            <a:endParaRPr lang="en-US"/>
+          </a:p>
+        </p:txBody>
+      </p:sp>
+    </p:spTree>
+    <p:extLst>
+      <p:ext uri="{BB962C8B-B14F-4D97-AF65-F5344CB8AC3E}">
+        <p14:creationId xmlns:p14="http://schemas.microsoft.com/office/powerpoint/2010/main" val="568039167"/>
+      </p:ext>
+    </p:extLst>
+  </p:cSld>
+  <p:clrMapOvr>
+    <a:masterClrMapping/>
+  </p:clrMapOvr>
+</p:notes>
+</file>
+
+<file path=ppt/notesSlides/notesSlide2.xml><?xml version="1.0" encoding="utf-8"?>
+<p:notes xmlns:a="http://schemas.openxmlformats.org/drawingml/2006/main" xmlns:r="http://schemas.openxmlformats.org/officeDocument/2006/relationships" xmlns:p="http://schemas.openxmlformats.org/presentationml/2006/main">
+  <p:cSld>
+    <p:spTree>
+      <p:nvGrpSpPr>
+        <p:cNvPr id="1" name=""/>
+        <p:cNvGrpSpPr/>
+        <p:nvPr/>
+      </p:nvGrpSpPr>
+      <p:grpSpPr>
+        <a:xfrm>
+          <a:off x="0" y="0"/>
+          <a:ext cx="0" cy="0"/>
+          <a:chOff x="0" y="0"/>
+          <a:chExt cx="0" cy="0"/>
+        </a:xfrm>
+      </p:grpSpPr>
+      <p:sp>
+        <p:nvSpPr>
+          <p:cNvPr id="2" name="Slide Image Placeholder 1"/>
+          <p:cNvSpPr>
+            <a:spLocks noGrp="1" noRot="1" noChangeAspect="1"/>
+          </p:cNvSpPr>
+          <p:nvPr>
+            <p:ph type="sldImg"/>
+          </p:nvPr>
+        </p:nvSpPr>
         <p:spPr>
           <a:xfrm>
             <a:off x="381000" y="685800"/>
@@ -551,7 +635,7 @@
 </p:notes>
 </file>
 
-<file path=ppt/notesSlides/notesSlide2.xml><?xml version="1.0" encoding="utf-8"?>
+<file path=ppt/notesSlides/notesSlide3.xml><?xml version="1.0" encoding="utf-8"?>
 <p:notes xmlns:a="http://schemas.openxmlformats.org/drawingml/2006/main" xmlns:r="http://schemas.openxmlformats.org/officeDocument/2006/relationships" xmlns:p="http://schemas.openxmlformats.org/presentationml/2006/main">
   <p:cSld>
     <p:spTree>
@@ -782,7 +866,7 @@
           <a:p>
             <a:fld id="{A978A291-C87E-4583-AB2D-5CAEB7F4C3DE}" type="datetime1">
               <a:rPr lang="en-US" smtClean="0"/>
-              <a:t>9/24/2025</a:t>
+              <a:t>9/25/2025</a:t>
             </a:fld>
             <a:endParaRPr lang="en-US"/>
           </a:p>
@@ -980,7 +1064,7 @@
           <a:p>
             <a:fld id="{D9948513-3721-474C-BE80-7871409E66CD}" type="datetime1">
               <a:rPr lang="en-US" smtClean="0"/>
-              <a:t>9/24/2025</a:t>
+              <a:t>9/25/2025</a:t>
             </a:fld>
             <a:endParaRPr lang="en-US"/>
           </a:p>
@@ -1188,7 +1272,7 @@
           <a:p>
             <a:fld id="{9C3FEB91-5253-4CC2-B144-C35513BB77D7}" type="datetime1">
               <a:rPr lang="en-US" smtClean="0"/>
-              <a:t>9/24/2025</a:t>
+              <a:t>9/25/2025</a:t>
             </a:fld>
             <a:endParaRPr lang="en-US"/>
           </a:p>
@@ -1386,7 +1470,7 @@
           <a:p>
             <a:fld id="{09779B33-F1DD-498D-93C7-6B8EC548F6D2}" type="datetime1">
               <a:rPr lang="en-US" smtClean="0"/>
-              <a:t>9/24/2025</a:t>
+              <a:t>9/25/2025</a:t>
             </a:fld>
             <a:endParaRPr lang="en-US"/>
           </a:p>
@@ -1696,7 +1780,7 @@
           <a:p>
             <a:fld id="{6820CCE4-48AB-4521-B222-52BFE717148C}" type="datetime1">
               <a:rPr lang="en-US" smtClean="0"/>
-              <a:t>9/24/2025</a:t>
+              <a:t>9/25/2025</a:t>
             </a:fld>
             <a:endParaRPr lang="en-US"/>
           </a:p>
@@ -1961,7 +2045,7 @@
           <a:p>
             <a:fld id="{A3A19DA7-183B-4551-9BD3-7C8E51B9184E}" type="datetime1">
               <a:rPr lang="en-US" smtClean="0"/>
-              <a:t>9/24/2025</a:t>
+              <a:t>9/25/2025</a:t>
             </a:fld>
             <a:endParaRPr lang="en-US"/>
           </a:p>
@@ -2373,7 +2457,7 @@
           <a:p>
             <a:fld id="{4A926BFC-E9D5-40BE-8176-572BC6F88714}" type="datetime1">
               <a:rPr lang="en-US" smtClean="0"/>
-              <a:t>9/24/2025</a:t>
+              <a:t>9/25/2025</a:t>
             </a:fld>
             <a:endParaRPr lang="en-US"/>
           </a:p>
@@ -2514,7 +2598,7 @@
           <a:p>
             <a:fld id="{605F6A97-0388-4AFE-AA88-9F8EE659E9FB}" type="datetime1">
               <a:rPr lang="en-US" smtClean="0"/>
-              <a:t>9/24/2025</a:t>
+              <a:t>9/25/2025</a:t>
             </a:fld>
             <a:endParaRPr lang="en-US"/>
           </a:p>
@@ -2662,7 +2746,7 @@
           <a:p>
             <a:fld id="{97CBCB5A-D4E0-47ED-AB71-73E5049E5258}" type="datetime1">
               <a:rPr lang="en-US" smtClean="0"/>
-              <a:t>9/24/2025</a:t>
+              <a:t>9/25/2025</a:t>
             </a:fld>
             <a:endParaRPr lang="en-US"/>
           </a:p>
@@ -2973,7 +3057,7 @@
           <a:p>
             <a:fld id="{62FB721B-115B-4B8B-AFC8-140F455CE774}" type="datetime1">
               <a:rPr lang="en-US" smtClean="0"/>
-              <a:t>9/24/2025</a:t>
+              <a:t>9/25/2025</a:t>
             </a:fld>
             <a:endParaRPr lang="en-US"/>
           </a:p>
@@ -3261,7 +3345,7 @@
           <a:p>
             <a:fld id="{E32E6149-AA0E-47F5-B01B-3D90BEF64480}" type="datetime1">
               <a:rPr lang="en-US" smtClean="0"/>
-              <a:t>9/24/2025</a:t>
+              <a:t>9/25/2025</a:t>
             </a:fld>
             <a:endParaRPr lang="en-US"/>
           </a:p>
@@ -3503,7 +3587,7 @@
           <a:p>
             <a:fld id="{B9BE06C6-629D-4C3F-AD68-BEBDFC283B8F}" type="datetime1">
               <a:rPr lang="en-US" smtClean="0"/>
-              <a:t>9/24/2025</a:t>
+              <a:t>9/25/2025</a:t>
             </a:fld>
             <a:endParaRPr lang="en-US"/>
           </a:p>
@@ -4227,7 +4311,7 @@
           </a:ln>
           <a:extLst>
             <a:ext uri="{C572A759-6A51-4108-AA02-DFA0A04FC94B}">
-              <ma14:wrappingTextBoxFlag xmlns:ma14="http://schemas.microsoft.com/office/mac/drawingml/2011/main" xmlns="" val="1"/>
+              <ma14:wrappingTextBoxFlag xmlns="" xmlns:ma14="http://schemas.microsoft.com/office/mac/drawingml/2011/main" val="1"/>
             </a:ext>
           </a:extLst>
         </p:spPr>
@@ -11670,7 +11754,7 @@
             <a:effectLst/>
             <a:extLst>
               <a:ext uri="{C572A759-6A51-4108-AA02-DFA0A04FC94B}">
-                <ma14:wrappingTextBoxFlag xmlns:ma14="http://schemas.microsoft.com/office/mac/drawingml/2011/main" xmlns="" val="1"/>
+                <ma14:wrappingTextBoxFlag xmlns="" xmlns:ma14="http://schemas.microsoft.com/office/mac/drawingml/2011/main" val="1"/>
               </a:ext>
             </a:extLst>
           </p:spPr>
@@ -11773,7 +11857,7 @@
             <a:effectLst/>
             <a:extLst>
               <a:ext uri="{C572A759-6A51-4108-AA02-DFA0A04FC94B}">
-                <ma14:wrappingTextBoxFlag xmlns:ma14="http://schemas.microsoft.com/office/mac/drawingml/2011/main" xmlns="" val="1"/>
+                <ma14:wrappingTextBoxFlag xmlns="" xmlns:ma14="http://schemas.microsoft.com/office/mac/drawingml/2011/main" val="1"/>
               </a:ext>
             </a:extLst>
           </p:spPr>
@@ -11877,7 +11961,7 @@
             <a:effectLst/>
             <a:extLst>
               <a:ext uri="{C572A759-6A51-4108-AA02-DFA0A04FC94B}">
-                <ma14:wrappingTextBoxFlag xmlns:ma14="http://schemas.microsoft.com/office/mac/drawingml/2011/main" xmlns="" val="1"/>
+                <ma14:wrappingTextBoxFlag xmlns="" xmlns:ma14="http://schemas.microsoft.com/office/mac/drawingml/2011/main" val="1"/>
               </a:ext>
             </a:extLst>
           </p:spPr>
@@ -11980,7 +12064,7 @@
             <a:effectLst/>
             <a:extLst>
               <a:ext uri="{C572A759-6A51-4108-AA02-DFA0A04FC94B}">
-                <ma14:wrappingTextBoxFlag xmlns:ma14="http://schemas.microsoft.com/office/mac/drawingml/2011/main" xmlns="" val="1"/>
+                <ma14:wrappingTextBoxFlag xmlns="" xmlns:ma14="http://schemas.microsoft.com/office/mac/drawingml/2011/main" val="1"/>
               </a:ext>
             </a:extLst>
           </p:spPr>
@@ -12083,7 +12167,7 @@
             <a:effectLst/>
             <a:extLst>
               <a:ext uri="{C572A759-6A51-4108-AA02-DFA0A04FC94B}">
-                <ma14:wrappingTextBoxFlag xmlns:ma14="http://schemas.microsoft.com/office/mac/drawingml/2011/main" xmlns="" val="1"/>
+                <ma14:wrappingTextBoxFlag xmlns="" xmlns:ma14="http://schemas.microsoft.com/office/mac/drawingml/2011/main" val="1"/>
               </a:ext>
             </a:extLst>
           </p:spPr>
@@ -12191,7 +12275,7 @@
             <a:effectLst/>
             <a:extLst>
               <a:ext uri="{C572A759-6A51-4108-AA02-DFA0A04FC94B}">
-                <ma14:wrappingTextBoxFlag xmlns:ma14="http://schemas.microsoft.com/office/mac/drawingml/2011/main" xmlns="" val="1"/>
+                <ma14:wrappingTextBoxFlag xmlns="" xmlns:ma14="http://schemas.microsoft.com/office/mac/drawingml/2011/main" val="1"/>
               </a:ext>
             </a:extLst>
           </p:spPr>
@@ -12294,7 +12378,7 @@
             <a:effectLst/>
             <a:extLst>
               <a:ext uri="{C572A759-6A51-4108-AA02-DFA0A04FC94B}">
-                <ma14:wrappingTextBoxFlag xmlns:ma14="http://schemas.microsoft.com/office/mac/drawingml/2011/main" xmlns="" val="1"/>
+                <ma14:wrappingTextBoxFlag xmlns="" xmlns:ma14="http://schemas.microsoft.com/office/mac/drawingml/2011/main" val="1"/>
               </a:ext>
             </a:extLst>
           </p:spPr>
@@ -12397,7 +12481,7 @@
             <a:effectLst/>
             <a:extLst>
               <a:ext uri="{C572A759-6A51-4108-AA02-DFA0A04FC94B}">
-                <ma14:wrappingTextBoxFlag xmlns:ma14="http://schemas.microsoft.com/office/mac/drawingml/2011/main" xmlns="" val="1"/>
+                <ma14:wrappingTextBoxFlag xmlns="" xmlns:ma14="http://schemas.microsoft.com/office/mac/drawingml/2011/main" val="1"/>
               </a:ext>
             </a:extLst>
           </p:spPr>
@@ -12511,7 +12595,7 @@
             <a:effectLst/>
             <a:extLst>
               <a:ext uri="{C572A759-6A51-4108-AA02-DFA0A04FC94B}">
-                <ma14:wrappingTextBoxFlag xmlns:ma14="http://schemas.microsoft.com/office/mac/drawingml/2011/main" xmlns="" val="1"/>
+                <ma14:wrappingTextBoxFlag xmlns="" xmlns:ma14="http://schemas.microsoft.com/office/mac/drawingml/2011/main" val="1"/>
               </a:ext>
             </a:extLst>
           </p:spPr>
@@ -12724,7 +12808,7 @@
               <a:effectLst/>
               <a:extLst>
                 <a:ext uri="{C572A759-6A51-4108-AA02-DFA0A04FC94B}">
-                  <ma14:wrappingTextBoxFlag xmlns:ma14="http://schemas.microsoft.com/office/mac/drawingml/2011/main" xmlns="" val="1"/>
+                  <ma14:wrappingTextBoxFlag xmlns="" xmlns:ma14="http://schemas.microsoft.com/office/mac/drawingml/2011/main" val="1"/>
                 </a:ext>
               </a:extLst>
             </p:spPr>
@@ -12828,7 +12912,7 @@
             <a:effectLst/>
             <a:extLst>
               <a:ext uri="{C572A759-6A51-4108-AA02-DFA0A04FC94B}">
-                <ma14:wrappingTextBoxFlag xmlns:ma14="http://schemas.microsoft.com/office/mac/drawingml/2011/main" xmlns="" val="1"/>
+                <ma14:wrappingTextBoxFlag xmlns="" xmlns:ma14="http://schemas.microsoft.com/office/mac/drawingml/2011/main" val="1"/>
               </a:ext>
             </a:extLst>
           </p:spPr>
@@ -12931,7 +13015,7 @@
             <a:effectLst/>
             <a:extLst>
               <a:ext uri="{C572A759-6A51-4108-AA02-DFA0A04FC94B}">
-                <ma14:wrappingTextBoxFlag xmlns:ma14="http://schemas.microsoft.com/office/mac/drawingml/2011/main" xmlns="" val="1"/>
+                <ma14:wrappingTextBoxFlag xmlns="" xmlns:ma14="http://schemas.microsoft.com/office/mac/drawingml/2011/main" val="1"/>
               </a:ext>
             </a:extLst>
           </p:spPr>
@@ -13088,7 +13172,7 @@
               <a:effectLst/>
               <a:extLst>
                 <a:ext uri="{C572A759-6A51-4108-AA02-DFA0A04FC94B}">
-                  <ma14:wrappingTextBoxFlag xmlns:ma14="http://schemas.microsoft.com/office/mac/drawingml/2011/main" xmlns="" val="1"/>
+                  <ma14:wrappingTextBoxFlag xmlns="" xmlns:ma14="http://schemas.microsoft.com/office/mac/drawingml/2011/main" val="1"/>
                 </a:ext>
               </a:extLst>
             </p:spPr>
@@ -13246,7 +13330,7 @@
               <a:effectLst/>
               <a:extLst>
                 <a:ext uri="{C572A759-6A51-4108-AA02-DFA0A04FC94B}">
-                  <ma14:wrappingTextBoxFlag xmlns:ma14="http://schemas.microsoft.com/office/mac/drawingml/2011/main" xmlns="" val="1"/>
+                  <ma14:wrappingTextBoxFlag xmlns="" xmlns:ma14="http://schemas.microsoft.com/office/mac/drawingml/2011/main" val="1"/>
                 </a:ext>
               </a:extLst>
             </p:spPr>
@@ -13652,7 +13736,7 @@
               <a:effectLst/>
               <a:extLst>
                 <a:ext uri="{C572A759-6A51-4108-AA02-DFA0A04FC94B}">
-                  <ma14:wrappingTextBoxFlag xmlns:ma14="http://schemas.microsoft.com/office/mac/drawingml/2011/main" xmlns="" val="1"/>
+                  <ma14:wrappingTextBoxFlag xmlns="" xmlns:ma14="http://schemas.microsoft.com/office/mac/drawingml/2011/main" val="1"/>
                 </a:ext>
               </a:extLst>
             </p:spPr>
@@ -13813,7 +13897,7 @@
               <a:effectLst/>
               <a:extLst>
                 <a:ext uri="{C572A759-6A51-4108-AA02-DFA0A04FC94B}">
-                  <ma14:wrappingTextBoxFlag xmlns:ma14="http://schemas.microsoft.com/office/mac/drawingml/2011/main" xmlns="" val="1"/>
+                  <ma14:wrappingTextBoxFlag xmlns="" xmlns:ma14="http://schemas.microsoft.com/office/mac/drawingml/2011/main" val="1"/>
                 </a:ext>
               </a:extLst>
             </p:spPr>
@@ -14210,7 +14294,7 @@
               <a:effectLst/>
               <a:extLst>
                 <a:ext uri="{C572A759-6A51-4108-AA02-DFA0A04FC94B}">
-                  <ma14:wrappingTextBoxFlag xmlns:ma14="http://schemas.microsoft.com/office/mac/drawingml/2011/main" xmlns="" val="1"/>
+                  <ma14:wrappingTextBoxFlag xmlns="" xmlns:ma14="http://schemas.microsoft.com/office/mac/drawingml/2011/main" val="1"/>
                 </a:ext>
               </a:extLst>
             </p:spPr>
@@ -14428,7 +14512,7 @@
               <a:effectLst/>
               <a:extLst>
                 <a:ext uri="{C572A759-6A51-4108-AA02-DFA0A04FC94B}">
-                  <ma14:wrappingTextBoxFlag xmlns:ma14="http://schemas.microsoft.com/office/mac/drawingml/2011/main" xmlns="" val="1"/>
+                  <ma14:wrappingTextBoxFlag xmlns="" xmlns:ma14="http://schemas.microsoft.com/office/mac/drawingml/2011/main" val="1"/>
                 </a:ext>
               </a:extLst>
             </p:spPr>
@@ -14596,7 +14680,7 @@
               <a:effectLst/>
               <a:extLst>
                 <a:ext uri="{C572A759-6A51-4108-AA02-DFA0A04FC94B}">
-                  <ma14:wrappingTextBoxFlag xmlns:ma14="http://schemas.microsoft.com/office/mac/drawingml/2011/main" xmlns="" val="1"/>
+                  <ma14:wrappingTextBoxFlag xmlns="" xmlns:ma14="http://schemas.microsoft.com/office/mac/drawingml/2011/main" val="1"/>
                 </a:ext>
               </a:extLst>
             </p:spPr>
@@ -15216,7 +15300,7 @@
               <a:effectLst/>
               <a:extLst>
                 <a:ext uri="{C572A759-6A51-4108-AA02-DFA0A04FC94B}">
-                  <ma14:wrappingTextBoxFlag xmlns:ma14="http://schemas.microsoft.com/office/mac/drawingml/2011/main" xmlns="" val="1"/>
+                  <ma14:wrappingTextBoxFlag xmlns="" xmlns:ma14="http://schemas.microsoft.com/office/mac/drawingml/2011/main" val="1"/>
                 </a:ext>
               </a:extLst>
             </p:spPr>
@@ -15269,7 +15353,7 @@
           </a:ln>
           <a:extLst>
             <a:ext uri="{C572A759-6A51-4108-AA02-DFA0A04FC94B}">
-              <ma14:wrappingTextBoxFlag xmlns:ma14="http://schemas.microsoft.com/office/mac/drawingml/2011/main" xmlns="" val="1"/>
+              <ma14:wrappingTextBoxFlag xmlns="" xmlns:ma14="http://schemas.microsoft.com/office/mac/drawingml/2011/main" val="1"/>
             </a:ext>
           </a:extLst>
         </p:spPr>
@@ -16644,7 +16728,7 @@
           </a:ln>
           <a:extLst>
             <a:ext uri="{C572A759-6A51-4108-AA02-DFA0A04FC94B}">
-              <ma14:wrappingTextBoxFlag xmlns:ma14="http://schemas.microsoft.com/office/mac/drawingml/2011/main" xmlns="" val="1"/>
+              <ma14:wrappingTextBoxFlag xmlns="" xmlns:ma14="http://schemas.microsoft.com/office/mac/drawingml/2011/main" val="1"/>
             </a:ext>
           </a:extLst>
         </p:spPr>
@@ -17017,7 +17101,7 @@
           </a:ln>
           <a:extLst>
             <a:ext uri="{C572A759-6A51-4108-AA02-DFA0A04FC94B}">
-              <ma14:wrappingTextBoxFlag xmlns:ma14="http://schemas.microsoft.com/office/mac/drawingml/2011/main" xmlns="" val="1"/>
+              <ma14:wrappingTextBoxFlag xmlns="" xmlns:ma14="http://schemas.microsoft.com/office/mac/drawingml/2011/main" val="1"/>
             </a:ext>
           </a:extLst>
         </p:spPr>
@@ -17077,7 +17161,7 @@
           </a:ln>
           <a:extLst>
             <a:ext uri="{C572A759-6A51-4108-AA02-DFA0A04FC94B}">
-              <ma14:wrappingTextBoxFlag xmlns:ma14="http://schemas.microsoft.com/office/mac/drawingml/2011/main" xmlns="" val="1"/>
+              <ma14:wrappingTextBoxFlag xmlns="" xmlns:ma14="http://schemas.microsoft.com/office/mac/drawingml/2011/main" val="1"/>
             </a:ext>
           </a:extLst>
         </p:spPr>
@@ -17671,7 +17755,7 @@
           <p:nvPr>
             <p:extLst>
               <p:ext uri="{D42A27DB-BD31-4B8C-83A1-F6EECF244321}">
-                <p14:modId xmlns:p14="http://schemas.microsoft.com/office/powerpoint/2010/main" val="2135031561"/>
+                <p14:modId xmlns:p14="http://schemas.microsoft.com/office/powerpoint/2010/main" val="3755200237"/>
               </p:ext>
             </p:extLst>
           </p:nvPr>
@@ -18104,7 +18188,7 @@
                           <a:ea typeface="D2CodingLigature Nerd Font" panose="020B0609020101020101" pitchFamily="49" charset="-127"/>
                           <a:cs typeface="JetBrains Mono" panose="02000009000000000000" pitchFamily="49" charset="0"/>
                         </a:rPr>
-                        <a:t>));</a:t>
+                        <a:t>))</a:t>
                       </a:r>
                       <a:endParaRPr lang="en-US" sz="1400" dirty="0">
                         <a:latin typeface="D2CodingLigature Nerd Font" panose="020B0609020101020101" pitchFamily="49" charset="-127"/>
@@ -18624,7 +18708,7 @@
                           <a:ea typeface="D2CodingLigature Nerd Font" panose="020B0609020101020101" pitchFamily="49" charset="-127"/>
                           <a:cs typeface="JetBrains Mono" panose="02000009000000000000" pitchFamily="49" charset="0"/>
                         </a:rPr>
-                        <a:t>);</a:t>
+                        <a:t>)</a:t>
                       </a:r>
                       <a:endParaRPr lang="en-US" sz="1400" dirty="0">
                         <a:latin typeface="D2CodingLigature Nerd Font" panose="020B0609020101020101" pitchFamily="49" charset="-127"/>
@@ -19140,7 +19224,7 @@
                           <a:ea typeface="D2CodingLigature Nerd Font" panose="020B0609020101020101" pitchFamily="49" charset="-127"/>
                           <a:cs typeface="JetBrains Mono" panose="02000009000000000000" pitchFamily="49" charset="0"/>
                         </a:rPr>
-                        <a:t>);</a:t>
+                        <a:t>)</a:t>
                       </a:r>
                       <a:endParaRPr lang="en-US" sz="1400" dirty="0">
                         <a:latin typeface="D2CodingLigature Nerd Font" panose="020B0609020101020101" pitchFamily="49" charset="-127"/>
@@ -19205,7 +19289,7 @@
           <p:nvPr>
             <p:extLst>
               <p:ext uri="{D42A27DB-BD31-4B8C-83A1-F6EECF244321}">
-                <p14:modId xmlns:p14="http://schemas.microsoft.com/office/powerpoint/2010/main" val="396285313"/>
+                <p14:modId xmlns:p14="http://schemas.microsoft.com/office/powerpoint/2010/main" val="3074478095"/>
               </p:ext>
             </p:extLst>
           </p:nvPr>
@@ -19614,7 +19698,7 @@
                           <a:ea typeface="D2CodingLigature Nerd Font" panose="020B0609020101020101" pitchFamily="49" charset="-127"/>
                           <a:cs typeface="JetBrains Mono" panose="02000009000000000000" pitchFamily="49" charset="0"/>
                         </a:rPr>
-                        <a:t>);</a:t>
+                        <a:t>)</a:t>
                       </a:r>
                       <a:endParaRPr lang="en-US" sz="1400" dirty="0">
                         <a:latin typeface="D2CodingLigature Nerd Font" panose="020B0609020101020101" pitchFamily="49" charset="-127"/>
@@ -19665,33 +19749,6 @@
                   <a:txBody>
                     <a:bodyPr/>
                     <a:lstStyle/>
-                    <a:p>
-                      <a:pPr marL="0" marR="0" lvl="0" indent="0" algn="ctr" defTabSz="914400" rtl="0" eaLnBrk="1" fontAlgn="auto" latinLnBrk="0" hangingPunct="1">
-                        <a:lnSpc>
-                          <a:spcPct val="100000"/>
-                        </a:lnSpc>
-                        <a:spcBef>
-                          <a:spcPts val="0"/>
-                        </a:spcBef>
-                        <a:spcAft>
-                          <a:spcPts val="0"/>
-                        </a:spcAft>
-                        <a:buClrTx/>
-                        <a:buSzTx/>
-                        <a:buFontTx/>
-                        <a:buNone/>
-                        <a:tabLst/>
-                        <a:defRPr/>
-                      </a:pPr>
-                      <a:endParaRPr lang="en-US" sz="1400" i="1" dirty="0">
-                        <a:solidFill>
-                          <a:srgbClr val="808080"/>
-                        </a:solidFill>
-                        <a:latin typeface="D2CodingLigature Nerd Font" panose="020B0609020101020101" pitchFamily="49" charset="-127"/>
-                        <a:ea typeface="D2CodingLigature Nerd Font" panose="020B0609020101020101" pitchFamily="49" charset="-127"/>
-                        <a:cs typeface="JetBrains Mono" panose="02000009000000000000" pitchFamily="49" charset="0"/>
-                      </a:endParaRPr>
-                    </a:p>
                     <a:p>
                       <a:pPr marL="0" marR="0" lvl="0" indent="0" algn="ctr" defTabSz="914400" rtl="0" eaLnBrk="1" fontAlgn="auto" latinLnBrk="0" hangingPunct="1">
                         <a:lnSpc>
@@ -19794,13 +19851,6 @@
                   <a:txBody>
                     <a:bodyPr/>
                     <a:lstStyle/>
-                    <a:p>
-                      <a:pPr algn="ctr"/>
-                      <a:endParaRPr lang="en-US" sz="1400" dirty="0">
-                        <a:latin typeface="D2CodingLigature Nerd Font" panose="020B0609020101020101" pitchFamily="49" charset="-127"/>
-                        <a:ea typeface="D2CodingLigature Nerd Font" panose="020B0609020101020101" pitchFamily="49" charset="-127"/>
-                      </a:endParaRPr>
-                    </a:p>
                     <a:p>
                       <a:pPr marL="0" marR="0" lvl="0" indent="0" algn="ctr" defTabSz="914400" rtl="0" eaLnBrk="1" fontAlgn="auto" latinLnBrk="0" hangingPunct="1">
                         <a:lnSpc>
@@ -20134,7 +20184,48 @@
                           <a:ea typeface="D2CodingLigature Nerd Font" panose="020B0609020101020101" pitchFamily="49" charset="-127"/>
                           <a:cs typeface="JetBrains Mono" panose="02000009000000000000" pitchFamily="49" charset="0"/>
                         </a:rPr>
-                        <a:t>);</a:t>
+                        <a:t>)</a:t>
+                      </a:r>
+                      <a:br>
+                        <a:rPr lang="en-US" sz="1400" dirty="0">
+                          <a:solidFill>
+                            <a:srgbClr val="000000"/>
+                          </a:solidFill>
+                          <a:effectLst/>
+                          <a:latin typeface="D2CodingLigature Nerd Font" panose="020B0609020101020101" pitchFamily="49" charset="-127"/>
+                          <a:ea typeface="D2CodingLigature Nerd Font" panose="020B0609020101020101" pitchFamily="49" charset="-127"/>
+                          <a:cs typeface="JetBrains Mono" panose="02000009000000000000" pitchFamily="49" charset="0"/>
+                        </a:rPr>
+                      </a:br>
+                      <a:r>
+                        <a:rPr lang="en-US" sz="1400" dirty="0">
+                          <a:solidFill>
+                            <a:srgbClr val="000000"/>
+                          </a:solidFill>
+                          <a:effectLst/>
+                          <a:latin typeface="Consolas" panose="020B0609020204030204" pitchFamily="49" charset="0"/>
+                        </a:rPr>
+                        <a:t>.</a:t>
+                      </a:r>
+                      <a:r>
+                        <a:rPr lang="en-US" sz="1400" dirty="0" err="1">
+                          <a:solidFill>
+                            <a:srgbClr val="000000"/>
+                          </a:solidFill>
+                          <a:effectLst/>
+                          <a:latin typeface="Consolas" panose="020B0609020204030204" pitchFamily="49" charset="0"/>
+                        </a:rPr>
+                        <a:t>castToSet</a:t>
+                      </a:r>
+                      <a:r>
+                        <a:rPr lang="en-US" sz="1400" dirty="0">
+                          <a:solidFill>
+                            <a:srgbClr val="000000"/>
+                          </a:solidFill>
+                          <a:effectLst/>
+                          <a:latin typeface="Consolas" panose="020B0609020204030204" pitchFamily="49" charset="0"/>
+                        </a:rPr>
+                        <a:t>()</a:t>
                       </a:r>
                       <a:endParaRPr lang="en-US" sz="1400" dirty="0">
                         <a:latin typeface="D2CodingLigature Nerd Font" panose="020B0609020101020101" pitchFamily="49" charset="-127"/>
@@ -20315,10 +20406,30 @@
                     <a:bodyPr/>
                     <a:lstStyle/>
                     <a:p>
-                      <a:pPr algn="ctr"/>
-                      <a:endParaRPr lang="en-US" sz="1400" dirty="0">
+                      <a:pPr marL="0" marR="0" lvl="0" indent="0" algn="ctr" defTabSz="914400" rtl="0" eaLnBrk="1" fontAlgn="auto" latinLnBrk="0" hangingPunct="1">
+                        <a:lnSpc>
+                          <a:spcPct val="100000"/>
+                        </a:lnSpc>
+                        <a:spcBef>
+                          <a:spcPts val="0"/>
+                        </a:spcBef>
+                        <a:spcAft>
+                          <a:spcPts val="0"/>
+                        </a:spcAft>
+                        <a:buClrTx/>
+                        <a:buSzTx/>
+                        <a:buFontTx/>
+                        <a:buNone/>
+                        <a:tabLst/>
+                        <a:defRPr/>
+                      </a:pPr>
+                      <a:endParaRPr lang="en-US" sz="1400" i="1" dirty="0">
+                        <a:solidFill>
+                          <a:srgbClr val="808080"/>
+                        </a:solidFill>
                         <a:latin typeface="D2CodingLigature Nerd Font" panose="020B0609020101020101" pitchFamily="49" charset="-127"/>
                         <a:ea typeface="D2CodingLigature Nerd Font" panose="020B0609020101020101" pitchFamily="49" charset="-127"/>
+                        <a:cs typeface="JetBrains Mono" panose="02000009000000000000" pitchFamily="49" charset="0"/>
                       </a:endParaRPr>
                     </a:p>
                     <a:p>
@@ -20670,7 +20781,7 @@
                           <a:ea typeface="D2CodingLigature Nerd Font" panose="020B0609020101020101" pitchFamily="49" charset="-127"/>
                           <a:cs typeface="JetBrains Mono" panose="02000009000000000000" pitchFamily="49" charset="0"/>
                         </a:rPr>
-                        <a:t>);</a:t>
+                        <a:t>)</a:t>
                       </a:r>
                       <a:endParaRPr lang="en-US" sz="1400" dirty="0">
                         <a:latin typeface="D2CodingLigature Nerd Font" panose="020B0609020101020101" pitchFamily="49" charset="-127"/>
@@ -21409,7 +21520,7 @@
           </a:ln>
           <a:extLst>
             <a:ext uri="{C572A759-6A51-4108-AA02-DFA0A04FC94B}">
-              <ma14:wrappingTextBoxFlag xmlns:ma14="http://schemas.microsoft.com/office/mac/drawingml/2011/main" xmlns:a14="http://schemas.microsoft.com/office/drawing/2010/main" xmlns:m="http://schemas.openxmlformats.org/officeDocument/2006/math" xmlns="" xmlns:lc="http://schemas.openxmlformats.org/drawingml/2006/lockedCanvas" val="1"/>
+              <ma14:wrappingTextBoxFlag xmlns:lc="http://schemas.openxmlformats.org/drawingml/2006/lockedCanvas" xmlns="" xmlns:m="http://schemas.openxmlformats.org/officeDocument/2006/math" xmlns:a14="http://schemas.microsoft.com/office/drawing/2010/main" xmlns:ma14="http://schemas.microsoft.com/office/mac/drawingml/2011/main" val="1"/>
             </a:ext>
           </a:extLst>
         </p:spPr>
@@ -21777,7 +21888,7 @@
           </a:ln>
           <a:extLst>
             <a:ext uri="{C572A759-6A51-4108-AA02-DFA0A04FC94B}">
-              <ma14:wrappingTextBoxFlag xmlns:ma14="http://schemas.microsoft.com/office/mac/drawingml/2011/main" xmlns:a14="http://schemas.microsoft.com/office/drawing/2010/main" xmlns:m="http://schemas.openxmlformats.org/officeDocument/2006/math" xmlns="" xmlns:lc="http://schemas.openxmlformats.org/drawingml/2006/lockedCanvas" val="1"/>
+              <ma14:wrappingTextBoxFlag xmlns:lc="http://schemas.openxmlformats.org/drawingml/2006/lockedCanvas" xmlns="" xmlns:m="http://schemas.openxmlformats.org/officeDocument/2006/math" xmlns:a14="http://schemas.microsoft.com/office/drawing/2010/main" xmlns:ma14="http://schemas.microsoft.com/office/mac/drawingml/2011/main" val="1"/>
             </a:ext>
           </a:extLst>
         </p:spPr>
@@ -22144,7 +22255,7 @@
           </a:ln>
           <a:extLst>
             <a:ext uri="{C572A759-6A51-4108-AA02-DFA0A04FC94B}">
-              <ma14:wrappingTextBoxFlag xmlns:ma14="http://schemas.microsoft.com/office/mac/drawingml/2011/main" xmlns:a14="http://schemas.microsoft.com/office/drawing/2010/main" xmlns:m="http://schemas.openxmlformats.org/officeDocument/2006/math" xmlns="" xmlns:lc="http://schemas.openxmlformats.org/drawingml/2006/lockedCanvas" val="1"/>
+              <ma14:wrappingTextBoxFlag xmlns:lc="http://schemas.openxmlformats.org/drawingml/2006/lockedCanvas" xmlns="" xmlns:m="http://schemas.openxmlformats.org/officeDocument/2006/math" xmlns:a14="http://schemas.microsoft.com/office/drawing/2010/main" xmlns:ma14="http://schemas.microsoft.com/office/mac/drawingml/2011/main" val="1"/>
             </a:ext>
           </a:extLst>
         </p:spPr>
@@ -22501,7 +22612,7 @@
           </a:ln>
           <a:extLst>
             <a:ext uri="{C572A759-6A51-4108-AA02-DFA0A04FC94B}">
-              <ma14:wrappingTextBoxFlag xmlns:ma14="http://schemas.microsoft.com/office/mac/drawingml/2011/main" xmlns:a14="http://schemas.microsoft.com/office/drawing/2010/main" xmlns:m="http://schemas.openxmlformats.org/officeDocument/2006/math" xmlns="" xmlns:lc="http://schemas.openxmlformats.org/drawingml/2006/lockedCanvas" val="1"/>
+              <ma14:wrappingTextBoxFlag xmlns:lc="http://schemas.openxmlformats.org/drawingml/2006/lockedCanvas" xmlns="" xmlns:m="http://schemas.openxmlformats.org/officeDocument/2006/math" xmlns:a14="http://schemas.microsoft.com/office/drawing/2010/main" xmlns:ma14="http://schemas.microsoft.com/office/mac/drawingml/2011/main" val="1"/>
             </a:ext>
           </a:extLst>
         </p:spPr>
@@ -22850,7 +22961,7 @@
           </a:ln>
           <a:extLst>
             <a:ext uri="{C572A759-6A51-4108-AA02-DFA0A04FC94B}">
-              <ma14:wrappingTextBoxFlag xmlns:ma14="http://schemas.microsoft.com/office/mac/drawingml/2011/main" xmlns:a14="http://schemas.microsoft.com/office/drawing/2010/main" xmlns:m="http://schemas.openxmlformats.org/officeDocument/2006/math" xmlns="" xmlns:lc="http://schemas.openxmlformats.org/drawingml/2006/lockedCanvas" val="1"/>
+              <ma14:wrappingTextBoxFlag xmlns:lc="http://schemas.openxmlformats.org/drawingml/2006/lockedCanvas" xmlns="" xmlns:m="http://schemas.openxmlformats.org/officeDocument/2006/math" xmlns:a14="http://schemas.microsoft.com/office/drawing/2010/main" xmlns:ma14="http://schemas.microsoft.com/office/mac/drawingml/2011/main" val="1"/>
             </a:ext>
           </a:extLst>
         </p:spPr>
@@ -23207,7 +23318,7 @@
           </a:ln>
           <a:extLst>
             <a:ext uri="{C572A759-6A51-4108-AA02-DFA0A04FC94B}">
-              <ma14:wrappingTextBoxFlag xmlns:ma14="http://schemas.microsoft.com/office/mac/drawingml/2011/main" xmlns:a14="http://schemas.microsoft.com/office/drawing/2010/main" xmlns:m="http://schemas.openxmlformats.org/officeDocument/2006/math" xmlns="" xmlns:lc="http://schemas.openxmlformats.org/drawingml/2006/lockedCanvas" val="1"/>
+              <ma14:wrappingTextBoxFlag xmlns:lc="http://schemas.openxmlformats.org/drawingml/2006/lockedCanvas" xmlns="" xmlns:m="http://schemas.openxmlformats.org/officeDocument/2006/math" xmlns:a14="http://schemas.microsoft.com/office/drawing/2010/main" xmlns:ma14="http://schemas.microsoft.com/office/mac/drawingml/2011/main" val="1"/>
             </a:ext>
           </a:extLst>
         </p:spPr>
@@ -23556,7 +23667,7 @@
           </a:ln>
           <a:extLst>
             <a:ext uri="{C572A759-6A51-4108-AA02-DFA0A04FC94B}">
-              <ma14:wrappingTextBoxFlag xmlns:ma14="http://schemas.microsoft.com/office/mac/drawingml/2011/main" xmlns:a14="http://schemas.microsoft.com/office/drawing/2010/main" xmlns:m="http://schemas.openxmlformats.org/officeDocument/2006/math" xmlns="" xmlns:lc="http://schemas.openxmlformats.org/drawingml/2006/lockedCanvas" val="1"/>
+              <ma14:wrappingTextBoxFlag xmlns:lc="http://schemas.openxmlformats.org/drawingml/2006/lockedCanvas" xmlns="" xmlns:m="http://schemas.openxmlformats.org/officeDocument/2006/math" xmlns:a14="http://schemas.microsoft.com/office/drawing/2010/main" xmlns:ma14="http://schemas.microsoft.com/office/mac/drawingml/2011/main" val="1"/>
             </a:ext>
           </a:extLst>
         </p:spPr>
@@ -23920,7 +24031,7 @@
           </a:ln>
           <a:extLst>
             <a:ext uri="{C572A759-6A51-4108-AA02-DFA0A04FC94B}">
-              <ma14:wrappingTextBoxFlag xmlns:ma14="http://schemas.microsoft.com/office/mac/drawingml/2011/main" xmlns:a14="http://schemas.microsoft.com/office/drawing/2010/main" xmlns:m="http://schemas.openxmlformats.org/officeDocument/2006/math" xmlns="" xmlns:lc="http://schemas.openxmlformats.org/drawingml/2006/lockedCanvas" val="1"/>
+              <ma14:wrappingTextBoxFlag xmlns:lc="http://schemas.openxmlformats.org/drawingml/2006/lockedCanvas" xmlns="" xmlns:m="http://schemas.openxmlformats.org/officeDocument/2006/math" xmlns:a14="http://schemas.microsoft.com/office/drawing/2010/main" xmlns:ma14="http://schemas.microsoft.com/office/mac/drawingml/2011/main" val="1"/>
             </a:ext>
           </a:extLst>
         </p:spPr>
@@ -24259,7 +24370,7 @@
           </a:ln>
           <a:extLst>
             <a:ext uri="{C572A759-6A51-4108-AA02-DFA0A04FC94B}">
-              <ma14:wrappingTextBoxFlag xmlns:ma14="http://schemas.microsoft.com/office/mac/drawingml/2011/main" xmlns:a14="http://schemas.microsoft.com/office/drawing/2010/main" xmlns:m="http://schemas.openxmlformats.org/officeDocument/2006/math" xmlns="" xmlns:lc="http://schemas.openxmlformats.org/drawingml/2006/lockedCanvas" val="1"/>
+              <ma14:wrappingTextBoxFlag xmlns:lc="http://schemas.openxmlformats.org/drawingml/2006/lockedCanvas" xmlns="" xmlns:m="http://schemas.openxmlformats.org/officeDocument/2006/math" xmlns:a14="http://schemas.microsoft.com/office/drawing/2010/main" xmlns:ma14="http://schemas.microsoft.com/office/mac/drawingml/2011/main" val="1"/>
             </a:ext>
           </a:extLst>
         </p:spPr>
@@ -24598,7 +24709,7 @@
           </a:ln>
           <a:extLst>
             <a:ext uri="{C572A759-6A51-4108-AA02-DFA0A04FC94B}">
-              <ma14:wrappingTextBoxFlag xmlns:ma14="http://schemas.microsoft.com/office/mac/drawingml/2011/main" xmlns:a14="http://schemas.microsoft.com/office/drawing/2010/main" xmlns:m="http://schemas.openxmlformats.org/officeDocument/2006/math" xmlns="" xmlns:lc="http://schemas.openxmlformats.org/drawingml/2006/lockedCanvas" val="1"/>
+              <ma14:wrappingTextBoxFlag xmlns:lc="http://schemas.openxmlformats.org/drawingml/2006/lockedCanvas" xmlns="" xmlns:m="http://schemas.openxmlformats.org/officeDocument/2006/math" xmlns:a14="http://schemas.microsoft.com/office/drawing/2010/main" xmlns:ma14="http://schemas.microsoft.com/office/mac/drawingml/2011/main" val="1"/>
             </a:ext>
           </a:extLst>
         </p:spPr>
@@ -24937,7 +25048,7 @@
           </a:ln>
           <a:extLst>
             <a:ext uri="{C572A759-6A51-4108-AA02-DFA0A04FC94B}">
-              <ma14:wrappingTextBoxFlag xmlns:ma14="http://schemas.microsoft.com/office/mac/drawingml/2011/main" xmlns:a14="http://schemas.microsoft.com/office/drawing/2010/main" xmlns:m="http://schemas.openxmlformats.org/officeDocument/2006/math" xmlns="" xmlns:lc="http://schemas.openxmlformats.org/drawingml/2006/lockedCanvas" val="1"/>
+              <ma14:wrappingTextBoxFlag xmlns:lc="http://schemas.openxmlformats.org/drawingml/2006/lockedCanvas" xmlns="" xmlns:m="http://schemas.openxmlformats.org/officeDocument/2006/math" xmlns:a14="http://schemas.microsoft.com/office/drawing/2010/main" xmlns:ma14="http://schemas.microsoft.com/office/mac/drawingml/2011/main" val="1"/>
             </a:ext>
           </a:extLst>
         </p:spPr>
@@ -25306,7 +25417,7 @@
           </a:ln>
           <a:extLst>
             <a:ext uri="{C572A759-6A51-4108-AA02-DFA0A04FC94B}">
-              <ma14:wrappingTextBoxFlag xmlns:ma14="http://schemas.microsoft.com/office/mac/drawingml/2011/main" xmlns:a14="http://schemas.microsoft.com/office/drawing/2010/main" xmlns:m="http://schemas.openxmlformats.org/officeDocument/2006/math" xmlns="" xmlns:lc="http://schemas.openxmlformats.org/drawingml/2006/lockedCanvas" val="1"/>
+              <ma14:wrappingTextBoxFlag xmlns:lc="http://schemas.openxmlformats.org/drawingml/2006/lockedCanvas" xmlns="" xmlns:m="http://schemas.openxmlformats.org/officeDocument/2006/math" xmlns:a14="http://schemas.microsoft.com/office/drawing/2010/main" xmlns:ma14="http://schemas.microsoft.com/office/mac/drawingml/2011/main" val="1"/>
             </a:ext>
           </a:extLst>
         </p:spPr>
@@ -25663,7 +25774,7 @@
           </a:ln>
           <a:extLst>
             <a:ext uri="{C572A759-6A51-4108-AA02-DFA0A04FC94B}">
-              <ma14:wrappingTextBoxFlag xmlns:ma14="http://schemas.microsoft.com/office/mac/drawingml/2011/main" xmlns:a14="http://schemas.microsoft.com/office/drawing/2010/main" xmlns:m="http://schemas.openxmlformats.org/officeDocument/2006/math" xmlns="" xmlns:lc="http://schemas.openxmlformats.org/drawingml/2006/lockedCanvas" val="1"/>
+              <ma14:wrappingTextBoxFlag xmlns:lc="http://schemas.openxmlformats.org/drawingml/2006/lockedCanvas" xmlns="" xmlns:m="http://schemas.openxmlformats.org/officeDocument/2006/math" xmlns:a14="http://schemas.microsoft.com/office/drawing/2010/main" xmlns:ma14="http://schemas.microsoft.com/office/mac/drawingml/2011/main" val="1"/>
             </a:ext>
           </a:extLst>
         </p:spPr>
@@ -26002,7 +26113,7 @@
           </a:ln>
           <a:extLst>
             <a:ext uri="{C572A759-6A51-4108-AA02-DFA0A04FC94B}">
-              <ma14:wrappingTextBoxFlag xmlns:ma14="http://schemas.microsoft.com/office/mac/drawingml/2011/main" xmlns:a14="http://schemas.microsoft.com/office/drawing/2010/main" xmlns:m="http://schemas.openxmlformats.org/officeDocument/2006/math" xmlns="" xmlns:lc="http://schemas.openxmlformats.org/drawingml/2006/lockedCanvas" val="1"/>
+              <ma14:wrappingTextBoxFlag xmlns:lc="http://schemas.openxmlformats.org/drawingml/2006/lockedCanvas" xmlns="" xmlns:m="http://schemas.openxmlformats.org/officeDocument/2006/math" xmlns:a14="http://schemas.microsoft.com/office/drawing/2010/main" xmlns:ma14="http://schemas.microsoft.com/office/mac/drawingml/2011/main" val="1"/>
             </a:ext>
           </a:extLst>
         </p:spPr>
@@ -26341,7 +26452,7 @@
           </a:ln>
           <a:extLst>
             <a:ext uri="{C572A759-6A51-4108-AA02-DFA0A04FC94B}">
-              <ma14:wrappingTextBoxFlag xmlns:ma14="http://schemas.microsoft.com/office/mac/drawingml/2011/main" xmlns:a14="http://schemas.microsoft.com/office/drawing/2010/main" xmlns:m="http://schemas.openxmlformats.org/officeDocument/2006/math" xmlns="" xmlns:lc="http://schemas.openxmlformats.org/drawingml/2006/lockedCanvas" val="1"/>
+              <ma14:wrappingTextBoxFlag xmlns:lc="http://schemas.openxmlformats.org/drawingml/2006/lockedCanvas" xmlns="" xmlns:m="http://schemas.openxmlformats.org/officeDocument/2006/math" xmlns:a14="http://schemas.microsoft.com/office/drawing/2010/main" xmlns:ma14="http://schemas.microsoft.com/office/mac/drawingml/2011/main" val="1"/>
             </a:ext>
           </a:extLst>
         </p:spPr>
@@ -26683,7 +26794,7 @@
           </a:ln>
           <a:extLst>
             <a:ext uri="{C572A759-6A51-4108-AA02-DFA0A04FC94B}">
-              <ma14:wrappingTextBoxFlag xmlns:ma14="http://schemas.microsoft.com/office/mac/drawingml/2011/main" xmlns:a14="http://schemas.microsoft.com/office/drawing/2010/main" xmlns:m="http://schemas.openxmlformats.org/officeDocument/2006/math" xmlns="" xmlns:lc="http://schemas.openxmlformats.org/drawingml/2006/lockedCanvas" val="1"/>
+              <ma14:wrappingTextBoxFlag xmlns:lc="http://schemas.openxmlformats.org/drawingml/2006/lockedCanvas" xmlns="" xmlns:m="http://schemas.openxmlformats.org/officeDocument/2006/math" xmlns:a14="http://schemas.microsoft.com/office/drawing/2010/main" xmlns:ma14="http://schemas.microsoft.com/office/mac/drawingml/2011/main" val="1"/>
             </a:ext>
           </a:extLst>
         </p:spPr>
@@ -27724,7 +27835,7 @@
           </a:ln>
           <a:extLst>
             <a:ext uri="{C572A759-6A51-4108-AA02-DFA0A04FC94B}">
-              <ma14:wrappingTextBoxFlag xmlns:ma14="http://schemas.microsoft.com/office/mac/drawingml/2011/main" xmlns:a14="http://schemas.microsoft.com/office/drawing/2010/main" xmlns:m="http://schemas.openxmlformats.org/officeDocument/2006/math" xmlns="" xmlns:lc="http://schemas.openxmlformats.org/drawingml/2006/lockedCanvas" val="1"/>
+              <ma14:wrappingTextBoxFlag xmlns:lc="http://schemas.openxmlformats.org/drawingml/2006/lockedCanvas" xmlns="" xmlns:m="http://schemas.openxmlformats.org/officeDocument/2006/math" xmlns:a14="http://schemas.microsoft.com/office/drawing/2010/main" xmlns:ma14="http://schemas.microsoft.com/office/mac/drawingml/2011/main" val="1"/>
             </a:ext>
           </a:extLst>
         </p:spPr>
@@ -28081,7 +28192,7 @@
           </a:ln>
           <a:extLst>
             <a:ext uri="{C572A759-6A51-4108-AA02-DFA0A04FC94B}">
-              <ma14:wrappingTextBoxFlag xmlns:ma14="http://schemas.microsoft.com/office/mac/drawingml/2011/main" xmlns:a14="http://schemas.microsoft.com/office/drawing/2010/main" xmlns:m="http://schemas.openxmlformats.org/officeDocument/2006/math" xmlns="" xmlns:lc="http://schemas.openxmlformats.org/drawingml/2006/lockedCanvas" val="1"/>
+              <ma14:wrappingTextBoxFlag xmlns:lc="http://schemas.openxmlformats.org/drawingml/2006/lockedCanvas" xmlns="" xmlns:m="http://schemas.openxmlformats.org/officeDocument/2006/math" xmlns:a14="http://schemas.microsoft.com/office/drawing/2010/main" xmlns:ma14="http://schemas.microsoft.com/office/mac/drawingml/2011/main" val="1"/>
             </a:ext>
           </a:extLst>
         </p:spPr>
@@ -28635,7 +28746,7 @@
               <a:effectLst/>
               <a:extLst>
                 <a:ext uri="{C572A759-6A51-4108-AA02-DFA0A04FC94B}">
-                  <ma14:wrappingTextBoxFlag xmlns:ma14="http://schemas.microsoft.com/office/mac/drawingml/2011/main" xmlns="" val="1"/>
+                  <ma14:wrappingTextBoxFlag xmlns="" xmlns:ma14="http://schemas.microsoft.com/office/mac/drawingml/2011/main" val="1"/>
                 </a:ext>
               </a:extLst>
             </p:spPr>
@@ -28686,7 +28797,7 @@
             <a:effectLst/>
             <a:extLst>
               <a:ext uri="{C572A759-6A51-4108-AA02-DFA0A04FC94B}">
-                <ma14:wrappingTextBoxFlag xmlns:ma14="http://schemas.microsoft.com/office/mac/drawingml/2011/main" xmlns="" val="1"/>
+                <ma14:wrappingTextBoxFlag xmlns="" xmlns:ma14="http://schemas.microsoft.com/office/mac/drawingml/2011/main" val="1"/>
               </a:ext>
             </a:extLst>
           </p:spPr>
@@ -28909,7 +29020,7 @@
               <a:effectLst/>
               <a:extLst>
                 <a:ext uri="{C572A759-6A51-4108-AA02-DFA0A04FC94B}">
-                  <ma14:wrappingTextBoxFlag xmlns:ma14="http://schemas.microsoft.com/office/mac/drawingml/2011/main" xmlns="" val="1"/>
+                  <ma14:wrappingTextBoxFlag xmlns="" xmlns:ma14="http://schemas.microsoft.com/office/mac/drawingml/2011/main" val="1"/>
                 </a:ext>
               </a:extLst>
             </p:spPr>
@@ -28960,7 +29071,7 @@
             <a:effectLst/>
             <a:extLst>
               <a:ext uri="{C572A759-6A51-4108-AA02-DFA0A04FC94B}">
-                <ma14:wrappingTextBoxFlag xmlns:ma14="http://schemas.microsoft.com/office/mac/drawingml/2011/main" xmlns="" val="1"/>
+                <ma14:wrappingTextBoxFlag xmlns="" xmlns:ma14="http://schemas.microsoft.com/office/mac/drawingml/2011/main" val="1"/>
               </a:ext>
             </a:extLst>
           </p:spPr>
@@ -29138,7 +29249,7 @@
               <a:effectLst/>
               <a:extLst>
                 <a:ext uri="{C572A759-6A51-4108-AA02-DFA0A04FC94B}">
-                  <ma14:wrappingTextBoxFlag xmlns:ma14="http://schemas.microsoft.com/office/mac/drawingml/2011/main" xmlns="" val="1"/>
+                  <ma14:wrappingTextBoxFlag xmlns="" xmlns:ma14="http://schemas.microsoft.com/office/mac/drawingml/2011/main" val="1"/>
                 </a:ext>
               </a:extLst>
             </p:spPr>
@@ -29189,7 +29300,7 @@
             <a:effectLst/>
             <a:extLst>
               <a:ext uri="{C572A759-6A51-4108-AA02-DFA0A04FC94B}">
-                <ma14:wrappingTextBoxFlag xmlns:ma14="http://schemas.microsoft.com/office/mac/drawingml/2011/main" xmlns="" val="1"/>
+                <ma14:wrappingTextBoxFlag xmlns="" xmlns:ma14="http://schemas.microsoft.com/office/mac/drawingml/2011/main" val="1"/>
               </a:ext>
             </a:extLst>
           </p:spPr>
@@ -29468,7 +29579,7 @@
               <a:effectLst/>
               <a:extLst>
                 <a:ext uri="{C572A759-6A51-4108-AA02-DFA0A04FC94B}">
-                  <ma14:wrappingTextBoxFlag xmlns:ma14="http://schemas.microsoft.com/office/mac/drawingml/2011/main" xmlns="" val="1"/>
+                  <ma14:wrappingTextBoxFlag xmlns="" xmlns:ma14="http://schemas.microsoft.com/office/mac/drawingml/2011/main" val="1"/>
                 </a:ext>
               </a:extLst>
             </p:spPr>
@@ -29519,7 +29630,7 @@
             <a:effectLst/>
             <a:extLst>
               <a:ext uri="{C572A759-6A51-4108-AA02-DFA0A04FC94B}">
-                <ma14:wrappingTextBoxFlag xmlns:ma14="http://schemas.microsoft.com/office/mac/drawingml/2011/main" xmlns="" val="1"/>
+                <ma14:wrappingTextBoxFlag xmlns="" xmlns:ma14="http://schemas.microsoft.com/office/mac/drawingml/2011/main" val="1"/>
               </a:ext>
             </a:extLst>
           </p:spPr>
@@ -29737,7 +29848,7 @@
               <a:effectLst/>
               <a:extLst>
                 <a:ext uri="{C572A759-6A51-4108-AA02-DFA0A04FC94B}">
-                  <ma14:wrappingTextBoxFlag xmlns:ma14="http://schemas.microsoft.com/office/mac/drawingml/2011/main" xmlns="" val="1"/>
+                  <ma14:wrappingTextBoxFlag xmlns="" xmlns:ma14="http://schemas.microsoft.com/office/mac/drawingml/2011/main" val="1"/>
                 </a:ext>
               </a:extLst>
             </p:spPr>
@@ -29791,7 +29902,7 @@
             <a:effectLst/>
             <a:extLst>
               <a:ext uri="{C572A759-6A51-4108-AA02-DFA0A04FC94B}">
-                <ma14:wrappingTextBoxFlag xmlns:ma14="http://schemas.microsoft.com/office/mac/drawingml/2011/main" xmlns="" val="1"/>
+                <ma14:wrappingTextBoxFlag xmlns="" xmlns:ma14="http://schemas.microsoft.com/office/mac/drawingml/2011/main" val="1"/>
               </a:ext>
             </a:extLst>
           </p:spPr>
@@ -29996,7 +30107,7 @@
               <a:effectLst/>
               <a:extLst>
                 <a:ext uri="{C572A759-6A51-4108-AA02-DFA0A04FC94B}">
-                  <ma14:wrappingTextBoxFlag xmlns:ma14="http://schemas.microsoft.com/office/mac/drawingml/2011/main" xmlns="" val="1"/>
+                  <ma14:wrappingTextBoxFlag xmlns="" xmlns:ma14="http://schemas.microsoft.com/office/mac/drawingml/2011/main" val="1"/>
                 </a:ext>
               </a:extLst>
             </p:spPr>
@@ -30050,7 +30161,7 @@
             <a:effectLst/>
             <a:extLst>
               <a:ext uri="{C572A759-6A51-4108-AA02-DFA0A04FC94B}">
-                <ma14:wrappingTextBoxFlag xmlns:ma14="http://schemas.microsoft.com/office/mac/drawingml/2011/main" xmlns="" val="1"/>
+                <ma14:wrappingTextBoxFlag xmlns="" xmlns:ma14="http://schemas.microsoft.com/office/mac/drawingml/2011/main" val="1"/>
               </a:ext>
             </a:extLst>
           </p:spPr>
@@ -30292,7 +30403,7 @@
               <a:effectLst/>
               <a:extLst>
                 <a:ext uri="{C572A759-6A51-4108-AA02-DFA0A04FC94B}">
-                  <ma14:wrappingTextBoxFlag xmlns:ma14="http://schemas.microsoft.com/office/mac/drawingml/2011/main" xmlns="" val="1"/>
+                  <ma14:wrappingTextBoxFlag xmlns="" xmlns:ma14="http://schemas.microsoft.com/office/mac/drawingml/2011/main" val="1"/>
                 </a:ext>
               </a:extLst>
             </p:spPr>
@@ -30350,7 +30461,7 @@
             <a:effectLst/>
             <a:extLst>
               <a:ext uri="{C572A759-6A51-4108-AA02-DFA0A04FC94B}">
-                <ma14:wrappingTextBoxFlag xmlns:ma14="http://schemas.microsoft.com/office/mac/drawingml/2011/main" xmlns="" val="1"/>
+                <ma14:wrappingTextBoxFlag xmlns="" xmlns:ma14="http://schemas.microsoft.com/office/mac/drawingml/2011/main" val="1"/>
               </a:ext>
             </a:extLst>
           </p:spPr>

</xml_diff>

<commit_message>
adds a qr code for the project link
</commit_message>
<xml_diff>
--- a/RefactorToEcIntro.pptx
+++ b/RefactorToEcIntro.pptx
@@ -219,7 +219,7 @@
           <a:p>
             <a:fld id="{8CCF7272-9B1D-4C9A-BAA4-A2C3BF62B1D2}" type="datetimeFigureOut">
               <a:rPr lang="en-US" smtClean="0"/>
-              <a:t>9/26/2025</a:t>
+              <a:t>9/27/2025</a:t>
             </a:fld>
             <a:endParaRPr lang="en-US"/>
           </a:p>
@@ -973,9 +973,9 @@
           <a:bodyPr/>
           <a:lstStyle/>
           <a:p>
-            <a:fld id="{A978A291-C87E-4583-AB2D-5CAEB7F4C3DE}" type="datetime1">
+            <a:fld id="{68BAE448-34E0-46DC-9FDB-1B326907CA84}" type="datetime1">
               <a:rPr lang="en-US" smtClean="0"/>
-              <a:t>9/26/2025</a:t>
+              <a:t>9/27/2025</a:t>
             </a:fld>
             <a:endParaRPr lang="en-US"/>
           </a:p>
@@ -1171,9 +1171,9 @@
           <a:bodyPr/>
           <a:lstStyle/>
           <a:p>
-            <a:fld id="{D9948513-3721-474C-BE80-7871409E66CD}" type="datetime1">
+            <a:fld id="{BAC0C9A0-71EB-4C46-BFAE-DCF0AF3A0EC8}" type="datetime1">
               <a:rPr lang="en-US" smtClean="0"/>
-              <a:t>9/26/2025</a:t>
+              <a:t>9/27/2025</a:t>
             </a:fld>
             <a:endParaRPr lang="en-US"/>
           </a:p>
@@ -1379,9 +1379,9 @@
           <a:bodyPr/>
           <a:lstStyle/>
           <a:p>
-            <a:fld id="{9C3FEB91-5253-4CC2-B144-C35513BB77D7}" type="datetime1">
+            <a:fld id="{AB43F7C9-88A6-4437-8948-DF2F3F9B25C1}" type="datetime1">
               <a:rPr lang="en-US" smtClean="0"/>
-              <a:t>9/26/2025</a:t>
+              <a:t>9/27/2025</a:t>
             </a:fld>
             <a:endParaRPr lang="en-US"/>
           </a:p>
@@ -1577,9 +1577,9 @@
           <a:bodyPr/>
           <a:lstStyle/>
           <a:p>
-            <a:fld id="{09779B33-F1DD-498D-93C7-6B8EC548F6D2}" type="datetime1">
+            <a:fld id="{3B0593FE-CF93-4F9B-AC56-75BC55C6F32F}" type="datetime1">
               <a:rPr lang="en-US" smtClean="0"/>
-              <a:t>9/26/2025</a:t>
+              <a:t>9/27/2025</a:t>
             </a:fld>
             <a:endParaRPr lang="en-US"/>
           </a:p>
@@ -1887,9 +1887,9 @@
           <a:bodyPr/>
           <a:lstStyle/>
           <a:p>
-            <a:fld id="{6820CCE4-48AB-4521-B222-52BFE717148C}" type="datetime1">
+            <a:fld id="{54C29679-8FFF-4A98-A10B-7B9208840F9A}" type="datetime1">
               <a:rPr lang="en-US" smtClean="0"/>
-              <a:t>9/26/2025</a:t>
+              <a:t>9/27/2025</a:t>
             </a:fld>
             <a:endParaRPr lang="en-US"/>
           </a:p>
@@ -2152,9 +2152,9 @@
           <a:bodyPr/>
           <a:lstStyle/>
           <a:p>
-            <a:fld id="{A3A19DA7-183B-4551-9BD3-7C8E51B9184E}" type="datetime1">
+            <a:fld id="{C616605E-1528-4FCA-84AE-4988E530378F}" type="datetime1">
               <a:rPr lang="en-US" smtClean="0"/>
-              <a:t>9/26/2025</a:t>
+              <a:t>9/27/2025</a:t>
             </a:fld>
             <a:endParaRPr lang="en-US"/>
           </a:p>
@@ -2564,9 +2564,9 @@
           <a:bodyPr/>
           <a:lstStyle/>
           <a:p>
-            <a:fld id="{4A926BFC-E9D5-40BE-8176-572BC6F88714}" type="datetime1">
+            <a:fld id="{5C967F88-E15A-423E-8C0E-ED81B2AD200B}" type="datetime1">
               <a:rPr lang="en-US" smtClean="0"/>
-              <a:t>9/26/2025</a:t>
+              <a:t>9/27/2025</a:t>
             </a:fld>
             <a:endParaRPr lang="en-US"/>
           </a:p>
@@ -2705,9 +2705,9 @@
           <a:bodyPr/>
           <a:lstStyle/>
           <a:p>
-            <a:fld id="{605F6A97-0388-4AFE-AA88-9F8EE659E9FB}" type="datetime1">
+            <a:fld id="{7B77AEE9-0B70-4E11-9251-71473506E641}" type="datetime1">
               <a:rPr lang="en-US" smtClean="0"/>
-              <a:t>9/26/2025</a:t>
+              <a:t>9/27/2025</a:t>
             </a:fld>
             <a:endParaRPr lang="en-US"/>
           </a:p>
@@ -2853,9 +2853,9 @@
           <a:bodyPr/>
           <a:lstStyle/>
           <a:p>
-            <a:fld id="{97CBCB5A-D4E0-47ED-AB71-73E5049E5258}" type="datetime1">
+            <a:fld id="{D39A6C2F-4429-4DEF-9F7B-968D133361D9}" type="datetime1">
               <a:rPr lang="en-US" smtClean="0"/>
-              <a:t>9/26/2025</a:t>
+              <a:t>9/27/2025</a:t>
             </a:fld>
             <a:endParaRPr lang="en-US"/>
           </a:p>
@@ -3164,9 +3164,9 @@
           <a:bodyPr/>
           <a:lstStyle/>
           <a:p>
-            <a:fld id="{62FB721B-115B-4B8B-AFC8-140F455CE774}" type="datetime1">
+            <a:fld id="{E6A7DD99-E1A7-4CEB-A5F5-1115ADD4759D}" type="datetime1">
               <a:rPr lang="en-US" smtClean="0"/>
-              <a:t>9/26/2025</a:t>
+              <a:t>9/27/2025</a:t>
             </a:fld>
             <a:endParaRPr lang="en-US"/>
           </a:p>
@@ -3452,9 +3452,9 @@
           <a:bodyPr/>
           <a:lstStyle/>
           <a:p>
-            <a:fld id="{E32E6149-AA0E-47F5-B01B-3D90BEF64480}" type="datetime1">
+            <a:fld id="{4D6AC830-A156-4095-8DF1-654325C78F63}" type="datetime1">
               <a:rPr lang="en-US" smtClean="0"/>
-              <a:t>9/26/2025</a:t>
+              <a:t>9/27/2025</a:t>
             </a:fld>
             <a:endParaRPr lang="en-US"/>
           </a:p>
@@ -3694,9 +3694,9 @@
             </a:lvl1pPr>
           </a:lstStyle>
           <a:p>
-            <a:fld id="{B9BE06C6-629D-4C3F-AD68-BEBDFC283B8F}" type="datetime1">
+            <a:fld id="{F83568D0-A24C-431A-888C-8829CA6D36F6}" type="datetime1">
               <a:rPr lang="en-US" smtClean="0"/>
-              <a:t>9/26/2025</a:t>
+              <a:t>9/27/2025</a:t>
             </a:fld>
             <a:endParaRPr lang="en-US"/>
           </a:p>
@@ -4420,7 +4420,7 @@
           </a:ln>
           <a:extLst>
             <a:ext uri="{C572A759-6A51-4108-AA02-DFA0A04FC94B}">
-              <ma14:wrappingTextBoxFlag xmlns:ma14="http://schemas.microsoft.com/office/mac/drawingml/2011/main" xmlns="" val="1"/>
+              <ma14:wrappingTextBoxFlag xmlns="" xmlns:ma14="http://schemas.microsoft.com/office/mac/drawingml/2011/main" val="1"/>
             </a:ext>
           </a:extLst>
         </p:spPr>
@@ -11084,7 +11084,7 @@
           <a:p>
             <a:r>
               <a:rPr lang="en-US" dirty="0"/>
-              <a:t>Many learning resources available</a:t>
+              <a:t>Many resources available</a:t>
             </a:r>
           </a:p>
           <a:p>
@@ -11247,6 +11247,242 @@
           </a:p>
         </p:txBody>
       </p:sp>
+      <p:sp>
+        <p:nvSpPr>
+          <p:cNvPr id="5" name="Slide Number Placeholder 4">
+            <a:extLst>
+              <a:ext uri="{FF2B5EF4-FFF2-40B4-BE49-F238E27FC236}">
+                <a16:creationId xmlns:a16="http://schemas.microsoft.com/office/drawing/2014/main" id="{2D74ADB1-F041-31C0-CBCF-0B1C18D1EB3B}"/>
+              </a:ext>
+            </a:extLst>
+          </p:cNvPr>
+          <p:cNvSpPr>
+            <a:spLocks noGrp="1"/>
+          </p:cNvSpPr>
+          <p:nvPr>
+            <p:ph type="sldNum" sz="quarter" idx="12"/>
+          </p:nvPr>
+        </p:nvSpPr>
+        <p:spPr/>
+        <p:txBody>
+          <a:bodyPr/>
+          <a:lstStyle/>
+          <a:p>
+            <a:fld id="{6874CE7D-5D74-4EC3-A871-8F42005EC53C}" type="slidenum">
+              <a:rPr lang="en-US" smtClean="0"/>
+              <a:t>20</a:t>
+            </a:fld>
+            <a:endParaRPr lang="en-US"/>
+          </a:p>
+        </p:txBody>
+      </p:sp>
+      <p:grpSp>
+        <p:nvGrpSpPr>
+          <p:cNvPr id="11" name="Group 10">
+            <a:extLst>
+              <a:ext uri="{FF2B5EF4-FFF2-40B4-BE49-F238E27FC236}">
+                <a16:creationId xmlns:a16="http://schemas.microsoft.com/office/drawing/2014/main" id="{0C000AFC-9060-C264-9B3C-36DCB1F81D46}"/>
+              </a:ext>
+            </a:extLst>
+          </p:cNvPr>
+          <p:cNvGrpSpPr/>
+          <p:nvPr/>
+        </p:nvGrpSpPr>
+        <p:grpSpPr>
+          <a:xfrm>
+            <a:off x="9195438" y="1051560"/>
+            <a:ext cx="2158362" cy="2158362"/>
+            <a:chOff x="9195438" y="1051560"/>
+            <a:chExt cx="2158362" cy="2158362"/>
+          </a:xfrm>
+        </p:grpSpPr>
+        <p:pic>
+          <p:nvPicPr>
+            <p:cNvPr id="7" name="Picture 6">
+              <a:extLst>
+                <a:ext uri="{FF2B5EF4-FFF2-40B4-BE49-F238E27FC236}">
+                  <a16:creationId xmlns:a16="http://schemas.microsoft.com/office/drawing/2014/main" id="{D3350572-C203-D6AA-E140-206241D1B060}"/>
+                </a:ext>
+              </a:extLst>
+            </p:cNvPr>
+            <p:cNvPicPr>
+              <a:picLocks noChangeAspect="1"/>
+            </p:cNvPicPr>
+            <p:nvPr/>
+          </p:nvPicPr>
+          <p:blipFill>
+            <a:blip r:embed="rId5"/>
+            <a:stretch>
+              <a:fillRect/>
+            </a:stretch>
+          </p:blipFill>
+          <p:spPr>
+            <a:xfrm>
+              <a:off x="9195438" y="1051560"/>
+              <a:ext cx="2158362" cy="2158362"/>
+            </a:xfrm>
+            <a:prstGeom prst="rect">
+              <a:avLst/>
+            </a:prstGeom>
+          </p:spPr>
+        </p:pic>
+        <p:sp>
+          <p:nvSpPr>
+            <p:cNvPr id="8" name="Rectangle 7">
+              <a:extLst>
+                <a:ext uri="{FF2B5EF4-FFF2-40B4-BE49-F238E27FC236}">
+                  <a16:creationId xmlns:a16="http://schemas.microsoft.com/office/drawing/2014/main" id="{B116E0A4-743D-7099-2DC5-34DE0044E83B}"/>
+                </a:ext>
+              </a:extLst>
+            </p:cNvPr>
+            <p:cNvSpPr/>
+            <p:nvPr/>
+          </p:nvSpPr>
+          <p:spPr>
+            <a:xfrm>
+              <a:off x="9427528" y="1281694"/>
+              <a:ext cx="182880" cy="182880"/>
+            </a:xfrm>
+            <a:prstGeom prst="rect">
+              <a:avLst/>
+            </a:prstGeom>
+            <a:solidFill>
+              <a:srgbClr val="F7941E"/>
+            </a:solidFill>
+            <a:ln>
+              <a:noFill/>
+            </a:ln>
+          </p:spPr>
+          <p:style>
+            <a:lnRef idx="2">
+              <a:schemeClr val="accent1">
+                <a:shade val="15000"/>
+              </a:schemeClr>
+            </a:lnRef>
+            <a:fillRef idx="1">
+              <a:schemeClr val="accent1"/>
+            </a:fillRef>
+            <a:effectRef idx="0">
+              <a:schemeClr val="accent1"/>
+            </a:effectRef>
+            <a:fontRef idx="minor">
+              <a:schemeClr val="lt1"/>
+            </a:fontRef>
+          </p:style>
+          <p:txBody>
+            <a:bodyPr rtlCol="0" anchor="ctr"/>
+            <a:lstStyle/>
+            <a:p>
+              <a:pPr algn="ctr"/>
+              <a:endParaRPr lang="en-US"/>
+            </a:p>
+          </p:txBody>
+        </p:sp>
+        <p:sp>
+          <p:nvSpPr>
+            <p:cNvPr id="9" name="Rectangle 8">
+              <a:extLst>
+                <a:ext uri="{FF2B5EF4-FFF2-40B4-BE49-F238E27FC236}">
+                  <a16:creationId xmlns:a16="http://schemas.microsoft.com/office/drawing/2014/main" id="{6F400F7D-A022-93E4-7160-1AE33D99231A}"/>
+                </a:ext>
+              </a:extLst>
+            </p:cNvPr>
+            <p:cNvSpPr/>
+            <p:nvPr/>
+          </p:nvSpPr>
+          <p:spPr>
+            <a:xfrm>
+              <a:off x="10943908" y="1281694"/>
+              <a:ext cx="182880" cy="182880"/>
+            </a:xfrm>
+            <a:prstGeom prst="rect">
+              <a:avLst/>
+            </a:prstGeom>
+            <a:solidFill>
+              <a:srgbClr val="F7941E"/>
+            </a:solidFill>
+            <a:ln>
+              <a:noFill/>
+            </a:ln>
+          </p:spPr>
+          <p:style>
+            <a:lnRef idx="2">
+              <a:schemeClr val="accent1">
+                <a:shade val="15000"/>
+              </a:schemeClr>
+            </a:lnRef>
+            <a:fillRef idx="1">
+              <a:schemeClr val="accent1"/>
+            </a:fillRef>
+            <a:effectRef idx="0">
+              <a:schemeClr val="accent1"/>
+            </a:effectRef>
+            <a:fontRef idx="minor">
+              <a:schemeClr val="lt1"/>
+            </a:fontRef>
+          </p:style>
+          <p:txBody>
+            <a:bodyPr rtlCol="0" anchor="ctr"/>
+            <a:lstStyle/>
+            <a:p>
+              <a:pPr algn="ctr"/>
+              <a:endParaRPr lang="en-US"/>
+            </a:p>
+          </p:txBody>
+        </p:sp>
+        <p:sp>
+          <p:nvSpPr>
+            <p:cNvPr id="10" name="Rectangle 9">
+              <a:extLst>
+                <a:ext uri="{FF2B5EF4-FFF2-40B4-BE49-F238E27FC236}">
+                  <a16:creationId xmlns:a16="http://schemas.microsoft.com/office/drawing/2014/main" id="{2AB37440-1233-BC71-5B31-05C4B68B6F0E}"/>
+                </a:ext>
+              </a:extLst>
+            </p:cNvPr>
+            <p:cNvSpPr/>
+            <p:nvPr/>
+          </p:nvSpPr>
+          <p:spPr>
+            <a:xfrm>
+              <a:off x="9427528" y="2800614"/>
+              <a:ext cx="182880" cy="182880"/>
+            </a:xfrm>
+            <a:prstGeom prst="rect">
+              <a:avLst/>
+            </a:prstGeom>
+            <a:solidFill>
+              <a:srgbClr val="F7941E"/>
+            </a:solidFill>
+            <a:ln>
+              <a:noFill/>
+            </a:ln>
+          </p:spPr>
+          <p:style>
+            <a:lnRef idx="2">
+              <a:schemeClr val="accent1">
+                <a:shade val="15000"/>
+              </a:schemeClr>
+            </a:lnRef>
+            <a:fillRef idx="1">
+              <a:schemeClr val="accent1"/>
+            </a:fillRef>
+            <a:effectRef idx="0">
+              <a:schemeClr val="accent1"/>
+            </a:effectRef>
+            <a:fontRef idx="minor">
+              <a:schemeClr val="lt1"/>
+            </a:fontRef>
+          </p:style>
+          <p:txBody>
+            <a:bodyPr rtlCol="0" anchor="ctr"/>
+            <a:lstStyle/>
+            <a:p>
+              <a:pPr algn="ctr"/>
+              <a:endParaRPr lang="en-US"/>
+            </a:p>
+          </p:txBody>
+        </p:sp>
+      </p:grpSp>
     </p:spTree>
     <p:extLst>
       <p:ext uri="{BB962C8B-B14F-4D97-AF65-F5344CB8AC3E}">
@@ -12220,7 +12456,7 @@
             <a:effectLst/>
             <a:extLst>
               <a:ext uri="{C572A759-6A51-4108-AA02-DFA0A04FC94B}">
-                <ma14:wrappingTextBoxFlag xmlns:ma14="http://schemas.microsoft.com/office/mac/drawingml/2011/main" xmlns="" val="1"/>
+                <ma14:wrappingTextBoxFlag xmlns="" xmlns:ma14="http://schemas.microsoft.com/office/mac/drawingml/2011/main" val="1"/>
               </a:ext>
             </a:extLst>
           </p:spPr>
@@ -12323,7 +12559,7 @@
             <a:effectLst/>
             <a:extLst>
               <a:ext uri="{C572A759-6A51-4108-AA02-DFA0A04FC94B}">
-                <ma14:wrappingTextBoxFlag xmlns:ma14="http://schemas.microsoft.com/office/mac/drawingml/2011/main" xmlns="" val="1"/>
+                <ma14:wrappingTextBoxFlag xmlns="" xmlns:ma14="http://schemas.microsoft.com/office/mac/drawingml/2011/main" val="1"/>
               </a:ext>
             </a:extLst>
           </p:spPr>
@@ -12427,7 +12663,7 @@
             <a:effectLst/>
             <a:extLst>
               <a:ext uri="{C572A759-6A51-4108-AA02-DFA0A04FC94B}">
-                <ma14:wrappingTextBoxFlag xmlns:ma14="http://schemas.microsoft.com/office/mac/drawingml/2011/main" xmlns="" val="1"/>
+                <ma14:wrappingTextBoxFlag xmlns="" xmlns:ma14="http://schemas.microsoft.com/office/mac/drawingml/2011/main" val="1"/>
               </a:ext>
             </a:extLst>
           </p:spPr>
@@ -12530,7 +12766,7 @@
             <a:effectLst/>
             <a:extLst>
               <a:ext uri="{C572A759-6A51-4108-AA02-DFA0A04FC94B}">
-                <ma14:wrappingTextBoxFlag xmlns:ma14="http://schemas.microsoft.com/office/mac/drawingml/2011/main" xmlns="" val="1"/>
+                <ma14:wrappingTextBoxFlag xmlns="" xmlns:ma14="http://schemas.microsoft.com/office/mac/drawingml/2011/main" val="1"/>
               </a:ext>
             </a:extLst>
           </p:spPr>
@@ -12633,7 +12869,7 @@
             <a:effectLst/>
             <a:extLst>
               <a:ext uri="{C572A759-6A51-4108-AA02-DFA0A04FC94B}">
-                <ma14:wrappingTextBoxFlag xmlns:ma14="http://schemas.microsoft.com/office/mac/drawingml/2011/main" xmlns="" val="1"/>
+                <ma14:wrappingTextBoxFlag xmlns="" xmlns:ma14="http://schemas.microsoft.com/office/mac/drawingml/2011/main" val="1"/>
               </a:ext>
             </a:extLst>
           </p:spPr>
@@ -12741,7 +12977,7 @@
             <a:effectLst/>
             <a:extLst>
               <a:ext uri="{C572A759-6A51-4108-AA02-DFA0A04FC94B}">
-                <ma14:wrappingTextBoxFlag xmlns:ma14="http://schemas.microsoft.com/office/mac/drawingml/2011/main" xmlns="" val="1"/>
+                <ma14:wrappingTextBoxFlag xmlns="" xmlns:ma14="http://schemas.microsoft.com/office/mac/drawingml/2011/main" val="1"/>
               </a:ext>
             </a:extLst>
           </p:spPr>
@@ -12844,7 +13080,7 @@
             <a:effectLst/>
             <a:extLst>
               <a:ext uri="{C572A759-6A51-4108-AA02-DFA0A04FC94B}">
-                <ma14:wrappingTextBoxFlag xmlns:ma14="http://schemas.microsoft.com/office/mac/drawingml/2011/main" xmlns="" val="1"/>
+                <ma14:wrappingTextBoxFlag xmlns="" xmlns:ma14="http://schemas.microsoft.com/office/mac/drawingml/2011/main" val="1"/>
               </a:ext>
             </a:extLst>
           </p:spPr>
@@ -12947,7 +13183,7 @@
             <a:effectLst/>
             <a:extLst>
               <a:ext uri="{C572A759-6A51-4108-AA02-DFA0A04FC94B}">
-                <ma14:wrappingTextBoxFlag xmlns:ma14="http://schemas.microsoft.com/office/mac/drawingml/2011/main" xmlns="" val="1"/>
+                <ma14:wrappingTextBoxFlag xmlns="" xmlns:ma14="http://schemas.microsoft.com/office/mac/drawingml/2011/main" val="1"/>
               </a:ext>
             </a:extLst>
           </p:spPr>
@@ -13061,7 +13297,7 @@
             <a:effectLst/>
             <a:extLst>
               <a:ext uri="{C572A759-6A51-4108-AA02-DFA0A04FC94B}">
-                <ma14:wrappingTextBoxFlag xmlns:ma14="http://schemas.microsoft.com/office/mac/drawingml/2011/main" xmlns="" val="1"/>
+                <ma14:wrappingTextBoxFlag xmlns="" xmlns:ma14="http://schemas.microsoft.com/office/mac/drawingml/2011/main" val="1"/>
               </a:ext>
             </a:extLst>
           </p:spPr>
@@ -13274,7 +13510,7 @@
               <a:effectLst/>
               <a:extLst>
                 <a:ext uri="{C572A759-6A51-4108-AA02-DFA0A04FC94B}">
-                  <ma14:wrappingTextBoxFlag xmlns:ma14="http://schemas.microsoft.com/office/mac/drawingml/2011/main" xmlns="" val="1"/>
+                  <ma14:wrappingTextBoxFlag xmlns="" xmlns:ma14="http://schemas.microsoft.com/office/mac/drawingml/2011/main" val="1"/>
                 </a:ext>
               </a:extLst>
             </p:spPr>
@@ -13378,7 +13614,7 @@
             <a:effectLst/>
             <a:extLst>
               <a:ext uri="{C572A759-6A51-4108-AA02-DFA0A04FC94B}">
-                <ma14:wrappingTextBoxFlag xmlns:ma14="http://schemas.microsoft.com/office/mac/drawingml/2011/main" xmlns="" val="1"/>
+                <ma14:wrappingTextBoxFlag xmlns="" xmlns:ma14="http://schemas.microsoft.com/office/mac/drawingml/2011/main" val="1"/>
               </a:ext>
             </a:extLst>
           </p:spPr>
@@ -13481,7 +13717,7 @@
             <a:effectLst/>
             <a:extLst>
               <a:ext uri="{C572A759-6A51-4108-AA02-DFA0A04FC94B}">
-                <ma14:wrappingTextBoxFlag xmlns:ma14="http://schemas.microsoft.com/office/mac/drawingml/2011/main" xmlns="" val="1"/>
+                <ma14:wrappingTextBoxFlag xmlns="" xmlns:ma14="http://schemas.microsoft.com/office/mac/drawingml/2011/main" val="1"/>
               </a:ext>
             </a:extLst>
           </p:spPr>
@@ -13638,7 +13874,7 @@
               <a:effectLst/>
               <a:extLst>
                 <a:ext uri="{C572A759-6A51-4108-AA02-DFA0A04FC94B}">
-                  <ma14:wrappingTextBoxFlag xmlns:ma14="http://schemas.microsoft.com/office/mac/drawingml/2011/main" xmlns="" val="1"/>
+                  <ma14:wrappingTextBoxFlag xmlns="" xmlns:ma14="http://schemas.microsoft.com/office/mac/drawingml/2011/main" val="1"/>
                 </a:ext>
               </a:extLst>
             </p:spPr>
@@ -13796,7 +14032,7 @@
               <a:effectLst/>
               <a:extLst>
                 <a:ext uri="{C572A759-6A51-4108-AA02-DFA0A04FC94B}">
-                  <ma14:wrappingTextBoxFlag xmlns:ma14="http://schemas.microsoft.com/office/mac/drawingml/2011/main" xmlns="" val="1"/>
+                  <ma14:wrappingTextBoxFlag xmlns="" xmlns:ma14="http://schemas.microsoft.com/office/mac/drawingml/2011/main" val="1"/>
                 </a:ext>
               </a:extLst>
             </p:spPr>
@@ -14202,7 +14438,7 @@
               <a:effectLst/>
               <a:extLst>
                 <a:ext uri="{C572A759-6A51-4108-AA02-DFA0A04FC94B}">
-                  <ma14:wrappingTextBoxFlag xmlns:ma14="http://schemas.microsoft.com/office/mac/drawingml/2011/main" xmlns="" val="1"/>
+                  <ma14:wrappingTextBoxFlag xmlns="" xmlns:ma14="http://schemas.microsoft.com/office/mac/drawingml/2011/main" val="1"/>
                 </a:ext>
               </a:extLst>
             </p:spPr>
@@ -14363,7 +14599,7 @@
               <a:effectLst/>
               <a:extLst>
                 <a:ext uri="{C572A759-6A51-4108-AA02-DFA0A04FC94B}">
-                  <ma14:wrappingTextBoxFlag xmlns:ma14="http://schemas.microsoft.com/office/mac/drawingml/2011/main" xmlns="" val="1"/>
+                  <ma14:wrappingTextBoxFlag xmlns="" xmlns:ma14="http://schemas.microsoft.com/office/mac/drawingml/2011/main" val="1"/>
                 </a:ext>
               </a:extLst>
             </p:spPr>
@@ -14760,7 +14996,7 @@
               <a:effectLst/>
               <a:extLst>
                 <a:ext uri="{C572A759-6A51-4108-AA02-DFA0A04FC94B}">
-                  <ma14:wrappingTextBoxFlag xmlns:ma14="http://schemas.microsoft.com/office/mac/drawingml/2011/main" xmlns="" val="1"/>
+                  <ma14:wrappingTextBoxFlag xmlns="" xmlns:ma14="http://schemas.microsoft.com/office/mac/drawingml/2011/main" val="1"/>
                 </a:ext>
               </a:extLst>
             </p:spPr>
@@ -14978,7 +15214,7 @@
               <a:effectLst/>
               <a:extLst>
                 <a:ext uri="{C572A759-6A51-4108-AA02-DFA0A04FC94B}">
-                  <ma14:wrappingTextBoxFlag xmlns:ma14="http://schemas.microsoft.com/office/mac/drawingml/2011/main" xmlns="" val="1"/>
+                  <ma14:wrappingTextBoxFlag xmlns="" xmlns:ma14="http://schemas.microsoft.com/office/mac/drawingml/2011/main" val="1"/>
                 </a:ext>
               </a:extLst>
             </p:spPr>
@@ -15146,7 +15382,7 @@
               <a:effectLst/>
               <a:extLst>
                 <a:ext uri="{C572A759-6A51-4108-AA02-DFA0A04FC94B}">
-                  <ma14:wrappingTextBoxFlag xmlns:ma14="http://schemas.microsoft.com/office/mac/drawingml/2011/main" xmlns="" val="1"/>
+                  <ma14:wrappingTextBoxFlag xmlns="" xmlns:ma14="http://schemas.microsoft.com/office/mac/drawingml/2011/main" val="1"/>
                 </a:ext>
               </a:extLst>
             </p:spPr>
@@ -15766,7 +16002,7 @@
               <a:effectLst/>
               <a:extLst>
                 <a:ext uri="{C572A759-6A51-4108-AA02-DFA0A04FC94B}">
-                  <ma14:wrappingTextBoxFlag xmlns:ma14="http://schemas.microsoft.com/office/mac/drawingml/2011/main" xmlns="" val="1"/>
+                  <ma14:wrappingTextBoxFlag xmlns="" xmlns:ma14="http://schemas.microsoft.com/office/mac/drawingml/2011/main" val="1"/>
                 </a:ext>
               </a:extLst>
             </p:spPr>
@@ -15819,7 +16055,7 @@
           </a:ln>
           <a:extLst>
             <a:ext uri="{C572A759-6A51-4108-AA02-DFA0A04FC94B}">
-              <ma14:wrappingTextBoxFlag xmlns:ma14="http://schemas.microsoft.com/office/mac/drawingml/2011/main" xmlns="" val="1"/>
+              <ma14:wrappingTextBoxFlag xmlns="" xmlns:ma14="http://schemas.microsoft.com/office/mac/drawingml/2011/main" val="1"/>
             </a:ext>
           </a:extLst>
         </p:spPr>
@@ -17194,7 +17430,7 @@
           </a:ln>
           <a:extLst>
             <a:ext uri="{C572A759-6A51-4108-AA02-DFA0A04FC94B}">
-              <ma14:wrappingTextBoxFlag xmlns:ma14="http://schemas.microsoft.com/office/mac/drawingml/2011/main" xmlns="" val="1"/>
+              <ma14:wrappingTextBoxFlag xmlns="" xmlns:ma14="http://schemas.microsoft.com/office/mac/drawingml/2011/main" val="1"/>
             </a:ext>
           </a:extLst>
         </p:spPr>
@@ -17567,7 +17803,7 @@
           </a:ln>
           <a:extLst>
             <a:ext uri="{C572A759-6A51-4108-AA02-DFA0A04FC94B}">
-              <ma14:wrappingTextBoxFlag xmlns:ma14="http://schemas.microsoft.com/office/mac/drawingml/2011/main" xmlns="" val="1"/>
+              <ma14:wrappingTextBoxFlag xmlns="" xmlns:ma14="http://schemas.microsoft.com/office/mac/drawingml/2011/main" val="1"/>
             </a:ext>
           </a:extLst>
         </p:spPr>
@@ -17627,7 +17863,7 @@
           </a:ln>
           <a:extLst>
             <a:ext uri="{C572A759-6A51-4108-AA02-DFA0A04FC94B}">
-              <ma14:wrappingTextBoxFlag xmlns:ma14="http://schemas.microsoft.com/office/mac/drawingml/2011/main" xmlns="" val="1"/>
+              <ma14:wrappingTextBoxFlag xmlns="" xmlns:ma14="http://schemas.microsoft.com/office/mac/drawingml/2011/main" val="1"/>
             </a:ext>
           </a:extLst>
         </p:spPr>
@@ -26260,7 +26496,7 @@
           </a:ln>
           <a:extLst>
             <a:ext uri="{C572A759-6A51-4108-AA02-DFA0A04FC94B}">
-              <ma14:wrappingTextBoxFlag xmlns:ma14="http://schemas.microsoft.com/office/mac/drawingml/2011/main" xmlns:a14="http://schemas.microsoft.com/office/drawing/2010/main" xmlns:m="http://schemas.openxmlformats.org/officeDocument/2006/math" xmlns="" xmlns:lc="http://schemas.openxmlformats.org/drawingml/2006/lockedCanvas" val="1"/>
+              <ma14:wrappingTextBoxFlag xmlns:lc="http://schemas.openxmlformats.org/drawingml/2006/lockedCanvas" xmlns="" xmlns:m="http://schemas.openxmlformats.org/officeDocument/2006/math" xmlns:a14="http://schemas.microsoft.com/office/drawing/2010/main" xmlns:ma14="http://schemas.microsoft.com/office/mac/drawingml/2011/main" val="1"/>
             </a:ext>
           </a:extLst>
         </p:spPr>
@@ -26628,7 +26864,7 @@
           </a:ln>
           <a:extLst>
             <a:ext uri="{C572A759-6A51-4108-AA02-DFA0A04FC94B}">
-              <ma14:wrappingTextBoxFlag xmlns:ma14="http://schemas.microsoft.com/office/mac/drawingml/2011/main" xmlns:a14="http://schemas.microsoft.com/office/drawing/2010/main" xmlns:m="http://schemas.openxmlformats.org/officeDocument/2006/math" xmlns="" xmlns:lc="http://schemas.openxmlformats.org/drawingml/2006/lockedCanvas" val="1"/>
+              <ma14:wrappingTextBoxFlag xmlns:lc="http://schemas.openxmlformats.org/drawingml/2006/lockedCanvas" xmlns="" xmlns:m="http://schemas.openxmlformats.org/officeDocument/2006/math" xmlns:a14="http://schemas.microsoft.com/office/drawing/2010/main" xmlns:ma14="http://schemas.microsoft.com/office/mac/drawingml/2011/main" val="1"/>
             </a:ext>
           </a:extLst>
         </p:spPr>
@@ -26995,7 +27231,7 @@
           </a:ln>
           <a:extLst>
             <a:ext uri="{C572A759-6A51-4108-AA02-DFA0A04FC94B}">
-              <ma14:wrappingTextBoxFlag xmlns:ma14="http://schemas.microsoft.com/office/mac/drawingml/2011/main" xmlns:a14="http://schemas.microsoft.com/office/drawing/2010/main" xmlns:m="http://schemas.openxmlformats.org/officeDocument/2006/math" xmlns="" xmlns:lc="http://schemas.openxmlformats.org/drawingml/2006/lockedCanvas" val="1"/>
+              <ma14:wrappingTextBoxFlag xmlns:lc="http://schemas.openxmlformats.org/drawingml/2006/lockedCanvas" xmlns="" xmlns:m="http://schemas.openxmlformats.org/officeDocument/2006/math" xmlns:a14="http://schemas.microsoft.com/office/drawing/2010/main" xmlns:ma14="http://schemas.microsoft.com/office/mac/drawingml/2011/main" val="1"/>
             </a:ext>
           </a:extLst>
         </p:spPr>
@@ -27352,7 +27588,7 @@
           </a:ln>
           <a:extLst>
             <a:ext uri="{C572A759-6A51-4108-AA02-DFA0A04FC94B}">
-              <ma14:wrappingTextBoxFlag xmlns:ma14="http://schemas.microsoft.com/office/mac/drawingml/2011/main" xmlns:a14="http://schemas.microsoft.com/office/drawing/2010/main" xmlns:m="http://schemas.openxmlformats.org/officeDocument/2006/math" xmlns="" xmlns:lc="http://schemas.openxmlformats.org/drawingml/2006/lockedCanvas" val="1"/>
+              <ma14:wrappingTextBoxFlag xmlns:lc="http://schemas.openxmlformats.org/drawingml/2006/lockedCanvas" xmlns="" xmlns:m="http://schemas.openxmlformats.org/officeDocument/2006/math" xmlns:a14="http://schemas.microsoft.com/office/drawing/2010/main" xmlns:ma14="http://schemas.microsoft.com/office/mac/drawingml/2011/main" val="1"/>
             </a:ext>
           </a:extLst>
         </p:spPr>
@@ -27701,7 +27937,7 @@
           </a:ln>
           <a:extLst>
             <a:ext uri="{C572A759-6A51-4108-AA02-DFA0A04FC94B}">
-              <ma14:wrappingTextBoxFlag xmlns:ma14="http://schemas.microsoft.com/office/mac/drawingml/2011/main" xmlns:a14="http://schemas.microsoft.com/office/drawing/2010/main" xmlns:m="http://schemas.openxmlformats.org/officeDocument/2006/math" xmlns="" xmlns:lc="http://schemas.openxmlformats.org/drawingml/2006/lockedCanvas" val="1"/>
+              <ma14:wrappingTextBoxFlag xmlns:lc="http://schemas.openxmlformats.org/drawingml/2006/lockedCanvas" xmlns="" xmlns:m="http://schemas.openxmlformats.org/officeDocument/2006/math" xmlns:a14="http://schemas.microsoft.com/office/drawing/2010/main" xmlns:ma14="http://schemas.microsoft.com/office/mac/drawingml/2011/main" val="1"/>
             </a:ext>
           </a:extLst>
         </p:spPr>
@@ -28058,7 +28294,7 @@
           </a:ln>
           <a:extLst>
             <a:ext uri="{C572A759-6A51-4108-AA02-DFA0A04FC94B}">
-              <ma14:wrappingTextBoxFlag xmlns:ma14="http://schemas.microsoft.com/office/mac/drawingml/2011/main" xmlns:a14="http://schemas.microsoft.com/office/drawing/2010/main" xmlns:m="http://schemas.openxmlformats.org/officeDocument/2006/math" xmlns="" xmlns:lc="http://schemas.openxmlformats.org/drawingml/2006/lockedCanvas" val="1"/>
+              <ma14:wrappingTextBoxFlag xmlns:lc="http://schemas.openxmlformats.org/drawingml/2006/lockedCanvas" xmlns="" xmlns:m="http://schemas.openxmlformats.org/officeDocument/2006/math" xmlns:a14="http://schemas.microsoft.com/office/drawing/2010/main" xmlns:ma14="http://schemas.microsoft.com/office/mac/drawingml/2011/main" val="1"/>
             </a:ext>
           </a:extLst>
         </p:spPr>
@@ -28407,7 +28643,7 @@
           </a:ln>
           <a:extLst>
             <a:ext uri="{C572A759-6A51-4108-AA02-DFA0A04FC94B}">
-              <ma14:wrappingTextBoxFlag xmlns:ma14="http://schemas.microsoft.com/office/mac/drawingml/2011/main" xmlns:a14="http://schemas.microsoft.com/office/drawing/2010/main" xmlns:m="http://schemas.openxmlformats.org/officeDocument/2006/math" xmlns="" xmlns:lc="http://schemas.openxmlformats.org/drawingml/2006/lockedCanvas" val="1"/>
+              <ma14:wrappingTextBoxFlag xmlns:lc="http://schemas.openxmlformats.org/drawingml/2006/lockedCanvas" xmlns="" xmlns:m="http://schemas.openxmlformats.org/officeDocument/2006/math" xmlns:a14="http://schemas.microsoft.com/office/drawing/2010/main" xmlns:ma14="http://schemas.microsoft.com/office/mac/drawingml/2011/main" val="1"/>
             </a:ext>
           </a:extLst>
         </p:spPr>
@@ -28771,7 +29007,7 @@
           </a:ln>
           <a:extLst>
             <a:ext uri="{C572A759-6A51-4108-AA02-DFA0A04FC94B}">
-              <ma14:wrappingTextBoxFlag xmlns:ma14="http://schemas.microsoft.com/office/mac/drawingml/2011/main" xmlns:a14="http://schemas.microsoft.com/office/drawing/2010/main" xmlns:m="http://schemas.openxmlformats.org/officeDocument/2006/math" xmlns="" xmlns:lc="http://schemas.openxmlformats.org/drawingml/2006/lockedCanvas" val="1"/>
+              <ma14:wrappingTextBoxFlag xmlns:lc="http://schemas.openxmlformats.org/drawingml/2006/lockedCanvas" xmlns="" xmlns:m="http://schemas.openxmlformats.org/officeDocument/2006/math" xmlns:a14="http://schemas.microsoft.com/office/drawing/2010/main" xmlns:ma14="http://schemas.microsoft.com/office/mac/drawingml/2011/main" val="1"/>
             </a:ext>
           </a:extLst>
         </p:spPr>
@@ -29110,7 +29346,7 @@
           </a:ln>
           <a:extLst>
             <a:ext uri="{C572A759-6A51-4108-AA02-DFA0A04FC94B}">
-              <ma14:wrappingTextBoxFlag xmlns:ma14="http://schemas.microsoft.com/office/mac/drawingml/2011/main" xmlns:a14="http://schemas.microsoft.com/office/drawing/2010/main" xmlns:m="http://schemas.openxmlformats.org/officeDocument/2006/math" xmlns="" xmlns:lc="http://schemas.openxmlformats.org/drawingml/2006/lockedCanvas" val="1"/>
+              <ma14:wrappingTextBoxFlag xmlns:lc="http://schemas.openxmlformats.org/drawingml/2006/lockedCanvas" xmlns="" xmlns:m="http://schemas.openxmlformats.org/officeDocument/2006/math" xmlns:a14="http://schemas.microsoft.com/office/drawing/2010/main" xmlns:ma14="http://schemas.microsoft.com/office/mac/drawingml/2011/main" val="1"/>
             </a:ext>
           </a:extLst>
         </p:spPr>
@@ -29449,7 +29685,7 @@
           </a:ln>
           <a:extLst>
             <a:ext uri="{C572A759-6A51-4108-AA02-DFA0A04FC94B}">
-              <ma14:wrappingTextBoxFlag xmlns:ma14="http://schemas.microsoft.com/office/mac/drawingml/2011/main" xmlns:a14="http://schemas.microsoft.com/office/drawing/2010/main" xmlns:m="http://schemas.openxmlformats.org/officeDocument/2006/math" xmlns="" xmlns:lc="http://schemas.openxmlformats.org/drawingml/2006/lockedCanvas" val="1"/>
+              <ma14:wrappingTextBoxFlag xmlns:lc="http://schemas.openxmlformats.org/drawingml/2006/lockedCanvas" xmlns="" xmlns:m="http://schemas.openxmlformats.org/officeDocument/2006/math" xmlns:a14="http://schemas.microsoft.com/office/drawing/2010/main" xmlns:ma14="http://schemas.microsoft.com/office/mac/drawingml/2011/main" val="1"/>
             </a:ext>
           </a:extLst>
         </p:spPr>
@@ -29788,7 +30024,7 @@
           </a:ln>
           <a:extLst>
             <a:ext uri="{C572A759-6A51-4108-AA02-DFA0A04FC94B}">
-              <ma14:wrappingTextBoxFlag xmlns:ma14="http://schemas.microsoft.com/office/mac/drawingml/2011/main" xmlns:a14="http://schemas.microsoft.com/office/drawing/2010/main" xmlns:m="http://schemas.openxmlformats.org/officeDocument/2006/math" xmlns="" xmlns:lc="http://schemas.openxmlformats.org/drawingml/2006/lockedCanvas" val="1"/>
+              <ma14:wrappingTextBoxFlag xmlns:lc="http://schemas.openxmlformats.org/drawingml/2006/lockedCanvas" xmlns="" xmlns:m="http://schemas.openxmlformats.org/officeDocument/2006/math" xmlns:a14="http://schemas.microsoft.com/office/drawing/2010/main" xmlns:ma14="http://schemas.microsoft.com/office/mac/drawingml/2011/main" val="1"/>
             </a:ext>
           </a:extLst>
         </p:spPr>
@@ -30157,7 +30393,7 @@
           </a:ln>
           <a:extLst>
             <a:ext uri="{C572A759-6A51-4108-AA02-DFA0A04FC94B}">
-              <ma14:wrappingTextBoxFlag xmlns:ma14="http://schemas.microsoft.com/office/mac/drawingml/2011/main" xmlns:a14="http://schemas.microsoft.com/office/drawing/2010/main" xmlns:m="http://schemas.openxmlformats.org/officeDocument/2006/math" xmlns="" xmlns:lc="http://schemas.openxmlformats.org/drawingml/2006/lockedCanvas" val="1"/>
+              <ma14:wrappingTextBoxFlag xmlns:lc="http://schemas.openxmlformats.org/drawingml/2006/lockedCanvas" xmlns="" xmlns:m="http://schemas.openxmlformats.org/officeDocument/2006/math" xmlns:a14="http://schemas.microsoft.com/office/drawing/2010/main" xmlns:ma14="http://schemas.microsoft.com/office/mac/drawingml/2011/main" val="1"/>
             </a:ext>
           </a:extLst>
         </p:spPr>
@@ -30514,7 +30750,7 @@
           </a:ln>
           <a:extLst>
             <a:ext uri="{C572A759-6A51-4108-AA02-DFA0A04FC94B}">
-              <ma14:wrappingTextBoxFlag xmlns:ma14="http://schemas.microsoft.com/office/mac/drawingml/2011/main" xmlns:a14="http://schemas.microsoft.com/office/drawing/2010/main" xmlns:m="http://schemas.openxmlformats.org/officeDocument/2006/math" xmlns="" xmlns:lc="http://schemas.openxmlformats.org/drawingml/2006/lockedCanvas" val="1"/>
+              <ma14:wrappingTextBoxFlag xmlns:lc="http://schemas.openxmlformats.org/drawingml/2006/lockedCanvas" xmlns="" xmlns:m="http://schemas.openxmlformats.org/officeDocument/2006/math" xmlns:a14="http://schemas.microsoft.com/office/drawing/2010/main" xmlns:ma14="http://schemas.microsoft.com/office/mac/drawingml/2011/main" val="1"/>
             </a:ext>
           </a:extLst>
         </p:spPr>
@@ -30853,7 +31089,7 @@
           </a:ln>
           <a:extLst>
             <a:ext uri="{C572A759-6A51-4108-AA02-DFA0A04FC94B}">
-              <ma14:wrappingTextBoxFlag xmlns:ma14="http://schemas.microsoft.com/office/mac/drawingml/2011/main" xmlns:a14="http://schemas.microsoft.com/office/drawing/2010/main" xmlns:m="http://schemas.openxmlformats.org/officeDocument/2006/math" xmlns="" xmlns:lc="http://schemas.openxmlformats.org/drawingml/2006/lockedCanvas" val="1"/>
+              <ma14:wrappingTextBoxFlag xmlns:lc="http://schemas.openxmlformats.org/drawingml/2006/lockedCanvas" xmlns="" xmlns:m="http://schemas.openxmlformats.org/officeDocument/2006/math" xmlns:a14="http://schemas.microsoft.com/office/drawing/2010/main" xmlns:ma14="http://schemas.microsoft.com/office/mac/drawingml/2011/main" val="1"/>
             </a:ext>
           </a:extLst>
         </p:spPr>
@@ -31192,7 +31428,7 @@
           </a:ln>
           <a:extLst>
             <a:ext uri="{C572A759-6A51-4108-AA02-DFA0A04FC94B}">
-              <ma14:wrappingTextBoxFlag xmlns:ma14="http://schemas.microsoft.com/office/mac/drawingml/2011/main" xmlns:a14="http://schemas.microsoft.com/office/drawing/2010/main" xmlns:m="http://schemas.openxmlformats.org/officeDocument/2006/math" xmlns="" xmlns:lc="http://schemas.openxmlformats.org/drawingml/2006/lockedCanvas" val="1"/>
+              <ma14:wrappingTextBoxFlag xmlns:lc="http://schemas.openxmlformats.org/drawingml/2006/lockedCanvas" xmlns="" xmlns:m="http://schemas.openxmlformats.org/officeDocument/2006/math" xmlns:a14="http://schemas.microsoft.com/office/drawing/2010/main" xmlns:ma14="http://schemas.microsoft.com/office/mac/drawingml/2011/main" val="1"/>
             </a:ext>
           </a:extLst>
         </p:spPr>
@@ -31534,7 +31770,7 @@
           </a:ln>
           <a:extLst>
             <a:ext uri="{C572A759-6A51-4108-AA02-DFA0A04FC94B}">
-              <ma14:wrappingTextBoxFlag xmlns:ma14="http://schemas.microsoft.com/office/mac/drawingml/2011/main" xmlns:a14="http://schemas.microsoft.com/office/drawing/2010/main" xmlns:m="http://schemas.openxmlformats.org/officeDocument/2006/math" xmlns="" xmlns:lc="http://schemas.openxmlformats.org/drawingml/2006/lockedCanvas" val="1"/>
+              <ma14:wrappingTextBoxFlag xmlns:lc="http://schemas.openxmlformats.org/drawingml/2006/lockedCanvas" xmlns="" xmlns:m="http://schemas.openxmlformats.org/officeDocument/2006/math" xmlns:a14="http://schemas.microsoft.com/office/drawing/2010/main" xmlns:ma14="http://schemas.microsoft.com/office/mac/drawingml/2011/main" val="1"/>
             </a:ext>
           </a:extLst>
         </p:spPr>
@@ -32575,7 +32811,7 @@
           </a:ln>
           <a:extLst>
             <a:ext uri="{C572A759-6A51-4108-AA02-DFA0A04FC94B}">
-              <ma14:wrappingTextBoxFlag xmlns:ma14="http://schemas.microsoft.com/office/mac/drawingml/2011/main" xmlns:a14="http://schemas.microsoft.com/office/drawing/2010/main" xmlns:m="http://schemas.openxmlformats.org/officeDocument/2006/math" xmlns="" xmlns:lc="http://schemas.openxmlformats.org/drawingml/2006/lockedCanvas" val="1"/>
+              <ma14:wrappingTextBoxFlag xmlns:lc="http://schemas.openxmlformats.org/drawingml/2006/lockedCanvas" xmlns="" xmlns:m="http://schemas.openxmlformats.org/officeDocument/2006/math" xmlns:a14="http://schemas.microsoft.com/office/drawing/2010/main" xmlns:ma14="http://schemas.microsoft.com/office/mac/drawingml/2011/main" val="1"/>
             </a:ext>
           </a:extLst>
         </p:spPr>
@@ -32932,7 +33168,7 @@
           </a:ln>
           <a:extLst>
             <a:ext uri="{C572A759-6A51-4108-AA02-DFA0A04FC94B}">
-              <ma14:wrappingTextBoxFlag xmlns:ma14="http://schemas.microsoft.com/office/mac/drawingml/2011/main" xmlns:a14="http://schemas.microsoft.com/office/drawing/2010/main" xmlns:m="http://schemas.openxmlformats.org/officeDocument/2006/math" xmlns="" xmlns:lc="http://schemas.openxmlformats.org/drawingml/2006/lockedCanvas" val="1"/>
+              <ma14:wrappingTextBoxFlag xmlns:lc="http://schemas.openxmlformats.org/drawingml/2006/lockedCanvas" xmlns="" xmlns:m="http://schemas.openxmlformats.org/officeDocument/2006/math" xmlns:a14="http://schemas.microsoft.com/office/drawing/2010/main" xmlns:ma14="http://schemas.microsoft.com/office/mac/drawingml/2011/main" val="1"/>
             </a:ext>
           </a:extLst>
         </p:spPr>
@@ -33486,7 +33722,7 @@
               <a:effectLst/>
               <a:extLst>
                 <a:ext uri="{C572A759-6A51-4108-AA02-DFA0A04FC94B}">
-                  <ma14:wrappingTextBoxFlag xmlns:ma14="http://schemas.microsoft.com/office/mac/drawingml/2011/main" xmlns="" val="1"/>
+                  <ma14:wrappingTextBoxFlag xmlns="" xmlns:ma14="http://schemas.microsoft.com/office/mac/drawingml/2011/main" val="1"/>
                 </a:ext>
               </a:extLst>
             </p:spPr>
@@ -33537,7 +33773,7 @@
             <a:effectLst/>
             <a:extLst>
               <a:ext uri="{C572A759-6A51-4108-AA02-DFA0A04FC94B}">
-                <ma14:wrappingTextBoxFlag xmlns:ma14="http://schemas.microsoft.com/office/mac/drawingml/2011/main" xmlns="" val="1"/>
+                <ma14:wrappingTextBoxFlag xmlns="" xmlns:ma14="http://schemas.microsoft.com/office/mac/drawingml/2011/main" val="1"/>
               </a:ext>
             </a:extLst>
           </p:spPr>
@@ -33760,7 +33996,7 @@
               <a:effectLst/>
               <a:extLst>
                 <a:ext uri="{C572A759-6A51-4108-AA02-DFA0A04FC94B}">
-                  <ma14:wrappingTextBoxFlag xmlns:ma14="http://schemas.microsoft.com/office/mac/drawingml/2011/main" xmlns="" val="1"/>
+                  <ma14:wrappingTextBoxFlag xmlns="" xmlns:ma14="http://schemas.microsoft.com/office/mac/drawingml/2011/main" val="1"/>
                 </a:ext>
               </a:extLst>
             </p:spPr>
@@ -33811,7 +34047,7 @@
             <a:effectLst/>
             <a:extLst>
               <a:ext uri="{C572A759-6A51-4108-AA02-DFA0A04FC94B}">
-                <ma14:wrappingTextBoxFlag xmlns:ma14="http://schemas.microsoft.com/office/mac/drawingml/2011/main" xmlns="" val="1"/>
+                <ma14:wrappingTextBoxFlag xmlns="" xmlns:ma14="http://schemas.microsoft.com/office/mac/drawingml/2011/main" val="1"/>
               </a:ext>
             </a:extLst>
           </p:spPr>
@@ -33989,7 +34225,7 @@
               <a:effectLst/>
               <a:extLst>
                 <a:ext uri="{C572A759-6A51-4108-AA02-DFA0A04FC94B}">
-                  <ma14:wrappingTextBoxFlag xmlns:ma14="http://schemas.microsoft.com/office/mac/drawingml/2011/main" xmlns="" val="1"/>
+                  <ma14:wrappingTextBoxFlag xmlns="" xmlns:ma14="http://schemas.microsoft.com/office/mac/drawingml/2011/main" val="1"/>
                 </a:ext>
               </a:extLst>
             </p:spPr>
@@ -34040,7 +34276,7 @@
             <a:effectLst/>
             <a:extLst>
               <a:ext uri="{C572A759-6A51-4108-AA02-DFA0A04FC94B}">
-                <ma14:wrappingTextBoxFlag xmlns:ma14="http://schemas.microsoft.com/office/mac/drawingml/2011/main" xmlns="" val="1"/>
+                <ma14:wrappingTextBoxFlag xmlns="" xmlns:ma14="http://schemas.microsoft.com/office/mac/drawingml/2011/main" val="1"/>
               </a:ext>
             </a:extLst>
           </p:spPr>
@@ -34319,7 +34555,7 @@
               <a:effectLst/>
               <a:extLst>
                 <a:ext uri="{C572A759-6A51-4108-AA02-DFA0A04FC94B}">
-                  <ma14:wrappingTextBoxFlag xmlns:ma14="http://schemas.microsoft.com/office/mac/drawingml/2011/main" xmlns="" val="1"/>
+                  <ma14:wrappingTextBoxFlag xmlns="" xmlns:ma14="http://schemas.microsoft.com/office/mac/drawingml/2011/main" val="1"/>
                 </a:ext>
               </a:extLst>
             </p:spPr>
@@ -34370,7 +34606,7 @@
             <a:effectLst/>
             <a:extLst>
               <a:ext uri="{C572A759-6A51-4108-AA02-DFA0A04FC94B}">
-                <ma14:wrappingTextBoxFlag xmlns:ma14="http://schemas.microsoft.com/office/mac/drawingml/2011/main" xmlns="" val="1"/>
+                <ma14:wrappingTextBoxFlag xmlns="" xmlns:ma14="http://schemas.microsoft.com/office/mac/drawingml/2011/main" val="1"/>
               </a:ext>
             </a:extLst>
           </p:spPr>
@@ -34588,7 +34824,7 @@
               <a:effectLst/>
               <a:extLst>
                 <a:ext uri="{C572A759-6A51-4108-AA02-DFA0A04FC94B}">
-                  <ma14:wrappingTextBoxFlag xmlns:ma14="http://schemas.microsoft.com/office/mac/drawingml/2011/main" xmlns="" val="1"/>
+                  <ma14:wrappingTextBoxFlag xmlns="" xmlns:ma14="http://schemas.microsoft.com/office/mac/drawingml/2011/main" val="1"/>
                 </a:ext>
               </a:extLst>
             </p:spPr>
@@ -34642,7 +34878,7 @@
             <a:effectLst/>
             <a:extLst>
               <a:ext uri="{C572A759-6A51-4108-AA02-DFA0A04FC94B}">
-                <ma14:wrappingTextBoxFlag xmlns:ma14="http://schemas.microsoft.com/office/mac/drawingml/2011/main" xmlns="" val="1"/>
+                <ma14:wrappingTextBoxFlag xmlns="" xmlns:ma14="http://schemas.microsoft.com/office/mac/drawingml/2011/main" val="1"/>
               </a:ext>
             </a:extLst>
           </p:spPr>
@@ -34847,7 +35083,7 @@
               <a:effectLst/>
               <a:extLst>
                 <a:ext uri="{C572A759-6A51-4108-AA02-DFA0A04FC94B}">
-                  <ma14:wrappingTextBoxFlag xmlns:ma14="http://schemas.microsoft.com/office/mac/drawingml/2011/main" xmlns="" val="1"/>
+                  <ma14:wrappingTextBoxFlag xmlns="" xmlns:ma14="http://schemas.microsoft.com/office/mac/drawingml/2011/main" val="1"/>
                 </a:ext>
               </a:extLst>
             </p:spPr>
@@ -34901,7 +35137,7 @@
             <a:effectLst/>
             <a:extLst>
               <a:ext uri="{C572A759-6A51-4108-AA02-DFA0A04FC94B}">
-                <ma14:wrappingTextBoxFlag xmlns:ma14="http://schemas.microsoft.com/office/mac/drawingml/2011/main" xmlns="" val="1"/>
+                <ma14:wrappingTextBoxFlag xmlns="" xmlns:ma14="http://schemas.microsoft.com/office/mac/drawingml/2011/main" val="1"/>
               </a:ext>
             </a:extLst>
           </p:spPr>
@@ -35143,7 +35379,7 @@
               <a:effectLst/>
               <a:extLst>
                 <a:ext uri="{C572A759-6A51-4108-AA02-DFA0A04FC94B}">
-                  <ma14:wrappingTextBoxFlag xmlns:ma14="http://schemas.microsoft.com/office/mac/drawingml/2011/main" xmlns="" val="1"/>
+                  <ma14:wrappingTextBoxFlag xmlns="" xmlns:ma14="http://schemas.microsoft.com/office/mac/drawingml/2011/main" val="1"/>
                 </a:ext>
               </a:extLst>
             </p:spPr>
@@ -35201,7 +35437,7 @@
             <a:effectLst/>
             <a:extLst>
               <a:ext uri="{C572A759-6A51-4108-AA02-DFA0A04FC94B}">
-                <ma14:wrappingTextBoxFlag xmlns:ma14="http://schemas.microsoft.com/office/mac/drawingml/2011/main" xmlns="" val="1"/>
+                <ma14:wrappingTextBoxFlag xmlns="" xmlns:ma14="http://schemas.microsoft.com/office/mac/drawingml/2011/main" val="1"/>
               </a:ext>
             </a:extLst>
           </p:spPr>

</xml_diff>